<commit_message>
Docs/packaging cleanup for submission accuracy
- README: tool count 9 -> 10 (feedback_tool).
- Move brainstorm_board.jsx to docs/ideation/ with a banner clarifying it is
  early ideation (mentions LangGraph / Claude 3.5) and NOT the implemented
  architecture (plain tool-use loop, claude-sonnet-4-6).
- Deck + architecture diagram: relabel cascade_tool explicitly as ROADMAP /
  not in the working prototype, so a designed capability can't read as built.
  Regenerated MaintenanceWizard.pptx / .pdf / architecture.png.

Co-Authored-By: Claude Opus 4.8 <noreply@anthropic.com>
</commit_message>
<xml_diff>
--- a/docs/deck/MaintenanceWizard.pptx
+++ b/docs/deck/MaintenanceWizard.pptx
@@ -12554,7 +12554,7 @@
                 <a:ea typeface="Calibri" pitchFamily="34" charset="-122"/>
                 <a:cs typeface="Calibri" pitchFamily="34" charset="-120"/>
               </a:rPr>
-              <a:t>STEP 4.5 — Plant impact (designed): </a:t>
+              <a:t>STEP 4.5 — Plant impact  [ROADMAP — not in the prototype]: </a:t>
             </a:r>
             <a:pPr indent="0" marL="0">
               <a:buNone/>
@@ -12568,7 +12568,7 @@
                 <a:ea typeface="Calibri" pitchFamily="34" charset="-122"/>
                 <a:cs typeface="Calibri" pitchFamily="34" charset="-120"/>
               </a:rPr>
-              <a:t>cascade_tool computes downstream blast radius so an asset's priority reflects what it idles, not just its own health.</a:t>
+              <a:t>a designed cascade_tool would compute downstream blast radius so an asset's priority reflects what it idles, not just its own health.</a:t>
             </a:r>
             <a:endParaRPr lang="en-US" sz="1200" dirty="0"/>
           </a:p>

</xml_diff>

<commit_message>
Refresh MaintenanceWizard presentation deck
</commit_message>
<xml_diff>
--- a/docs/deck/MaintenanceWizard.pptx
+++ b/docs/deck/MaintenanceWizard.pptx
@@ -4,6 +4,9 @@
   <p:sldMasterIdLst>
     <p:sldMasterId id="2147483648" r:id="rId1"/>
   </p:sldMasterIdLst>
+  <p:notesMasterIdLst>
+    <p:notesMasterId r:id="rId16"/>
+  </p:notesMasterIdLst>
   <p:sldIdLst>
     <p:sldId id="256" r:id="rId2"/>
     <p:sldId id="257" r:id="rId3"/>
@@ -20,10 +23,7 @@
     <p:sldId id="268" r:id="rId14"/>
     <p:sldId id="269" r:id="rId15"/>
   </p:sldIdLst>
-  <p:notesMasterIdLst>
-    <p:notesMasterId r:id="rId16"/>
-  </p:notesMasterIdLst>
-  <p:sldSz cx="9144000" cy="5143500"/>
+  <p:sldSz cx="9144000" cy="5143500" type="screen16x9"/>
   <p:notesSz cx="5143500" cy="9144000"/>
   <p:defaultTextStyle>
     <a:lvl1pPr marL="0" algn="l" defTabSz="914400" rtl="0" eaLnBrk="1" latinLnBrk="0" hangingPunct="1">
@@ -117,13 +117,20 @@
       </a:defRPr>
     </a:lvl9pPr>
   </p:defaultTextStyle>
+  <p:extLst>
+    <p:ext uri="{EFAFB233-063F-42B5-8137-9DF3F51BA10A}">
+      <p15:sldGuideLst xmlns:p15="http://schemas.microsoft.com/office/powerpoint/2012/main"/>
+    </p:ext>
+  </p:extLst>
 </p:presentation>
 </file>
 
 <file path=ppt/charts/chart1.xml><?xml version="1.0" encoding="utf-8"?>
-<c:chartSpace xmlns:c="http://schemas.openxmlformats.org/drawingml/2006/chart" xmlns:a="http://schemas.openxmlformats.org/drawingml/2006/main" xmlns:r="http://schemas.openxmlformats.org/officeDocument/2006/relationships">
+<c:chartSpace xmlns:c="http://schemas.openxmlformats.org/drawingml/2006/chart" xmlns:a="http://schemas.openxmlformats.org/drawingml/2006/main" xmlns:r="http://schemas.openxmlformats.org/officeDocument/2006/relationships" xmlns:c16r2="http://schemas.microsoft.com/office/drawing/2015/06/chart">
   <c:date1904 val="0"/>
+  <c:lang val="en-US"/>
   <c:roundedCorners val="1"/>
+  <c:style val="2"/>
   <c:chart>
     <c:autoTitleDeleted val="1"/>
     <c:plotArea>
@@ -157,18 +164,26 @@
           <c:invertIfNegative val="0"/>
           <c:dLbls>
             <c:numFmt formatCode="#,##0" sourceLinked="0"/>
+            <c:spPr>
+              <a:noFill/>
+              <a:ln>
+                <a:noFill/>
+              </a:ln>
+              <a:effectLst/>
+            </c:spPr>
             <c:txPr>
               <a:bodyPr/>
               <a:lstStyle/>
               <a:p>
                 <a:pPr>
-                  <a:defRPr b="0" i="0" strike="noStrike" sz="950" u="none">
+                  <a:defRPr sz="950" b="0" i="0" u="none" strike="noStrike">
                     <a:solidFill>
                       <a:srgbClr val="16202E"/>
                     </a:solidFill>
                     <a:latin typeface="Arial"/>
                   </a:defRPr>
                 </a:pPr>
+                <a:endParaRPr lang="en-US"/>
               </a:p>
             </c:txPr>
             <c:showLegendKey val="0"/>
@@ -178,31 +193,34 @@
             <c:showPercent val="0"/>
             <c:showBubbleSize val="0"/>
             <c:showLeaderLines val="0"/>
+            <c:extLst>
+              <c:ext xmlns:c15="http://schemas.microsoft.com/office/drawing/2012/chart" uri="{CE6537A1-D6FC-4f65-9D91-7224C49458BB}">
+                <c15:showLeaderLines val="0"/>
+              </c:ext>
+            </c:extLst>
           </c:dLbls>
           <c:cat>
-            <c:multiLvlStrRef>
+            <c:strRef>
               <c:f>Sheet1!$A$2:$A$6</c:f>
-              <c:multiLvlStrCache>
+              <c:strCache>
                 <c:ptCount val="5"/>
-                <c:lvl>
-                  <c:pt idx="0">
-                    <c:v>vibration</c:v>
-                  </c:pt>
-                  <c:pt idx="1">
-                    <c:v>temperature</c:v>
-                  </c:pt>
-                  <c:pt idx="2">
-                    <c:v>pressure</c:v>
-                  </c:pt>
-                  <c:pt idx="3">
-                    <c:v>power</c:v>
-                  </c:pt>
-                  <c:pt idx="4">
-                    <c:v>humidity</c:v>
-                  </c:pt>
-                </c:lvl>
-              </c:multiLvlStrCache>
-            </c:multiLvlStrRef>
+                <c:pt idx="0">
+                  <c:v>vibration</c:v>
+                </c:pt>
+                <c:pt idx="1">
+                  <c:v>temperature</c:v>
+                </c:pt>
+                <c:pt idx="2">
+                  <c:v>pressure</c:v>
+                </c:pt>
+                <c:pt idx="3">
+                  <c:v>power</c:v>
+                </c:pt>
+                <c:pt idx="4">
+                  <c:v>humidity</c:v>
+                </c:pt>
+              </c:strCache>
+            </c:strRef>
           </c:cat>
           <c:val>
             <c:numRef>
@@ -228,36 +246,23 @@
               </c:numCache>
             </c:numRef>
           </c:val>
+          <c:extLst>
+            <c:ext xmlns:c16="http://schemas.microsoft.com/office/drawing/2014/chart" uri="{C3380CC4-5D6E-409C-BE32-E72D297353CC}">
+              <c16:uniqueId val="{00000000-ECFB-4AC8-8C55-CCD00097E915}"/>
+            </c:ext>
+          </c:extLst>
         </c:ser>
         <c:dLbls>
-          <c:numFmt formatCode="#,##0" sourceLinked="0"/>
-          <c:txPr>
-            <a:bodyPr/>
-            <a:lstStyle/>
-            <a:p>
-              <a:pPr>
-                <a:defRPr b="0" i="0" strike="noStrike" sz="950" u="none">
-                  <a:solidFill>
-                    <a:srgbClr val="16202E"/>
-                  </a:solidFill>
-                  <a:latin typeface="Arial"/>
-                </a:defRPr>
-              </a:pPr>
-            </a:p>
-          </c:txPr>
           <c:showLegendKey val="0"/>
           <c:showVal val="1"/>
           <c:showCatName val="0"/>
           <c:showSerName val="0"/>
           <c:showPercent val="0"/>
           <c:showBubbleSize val="0"/>
-          <c:showLeaderLines val="0"/>
         </c:dLbls>
         <c:gapWidth val="150"/>
-        <c:overlap val="0"/>
         <c:axId val="2094734554"/>
         <c:axId val="2094734552"/>
-        <c:axId val="2094734556"/>
       </c:barChart>
       <c:catAx>
         <c:axId val="2094734554"/>
@@ -298,6 +303,7 @@
         <c:crosses val="autoZero"/>
         <c:auto val="1"/>
         <c:lblAlgn val="ctr"/>
+        <c:lblOffset val="100"/>
         <c:noMultiLvlLbl val="1"/>
       </c:catAx>
       <c:valAx>
@@ -360,6 +366,7 @@
     </c:plotArea>
     <c:plotVisOnly val="1"/>
     <c:dispBlanksAs val="span"/>
+    <c:showDLblsOverMax val="1"/>
   </c:chart>
   <c:spPr>
     <a:solidFill>
@@ -398,234 +405,10 @@
           <a:chExt cx="0" cy="0"/>
         </a:xfrm>
       </p:grpSpPr>
-      <p:sp>
-        <p:nvSpPr>
-          <p:cNvPr id="2" name="Header Placeholder 1"/>
-          <p:cNvSpPr>
-            <a:spLocks noGrp="1"/>
-          </p:cNvSpPr>
-          <p:nvPr>
-            <p:ph type="hdr" sz="quarter"/>
-          </p:nvPr>
-        </p:nvSpPr>
-        <p:spPr>
-          <a:xfrm>
-            <a:off x="0" y="0"/>
-            <a:ext cx="2971800" cy="458788"/>
-          </a:xfrm>
-          <a:prstGeom prst="rect">
-            <a:avLst/>
-          </a:prstGeom>
-        </p:spPr>
-        <p:txBody>
-          <a:bodyPr vert="horz" lIns="91440" tIns="45720" rIns="91440" bIns="45720" rtlCol="0"/>
-          <a:lstStyle>
-            <a:lvl1pPr algn="l">
-              <a:defRPr sz="1200"/>
-            </a:lvl1pPr>
-          </a:lstStyle>
-          <a:p>
-            <a:endParaRPr lang="en-US"/>
-          </a:p>
-        </p:txBody>
-      </p:sp>
-      <p:sp>
-        <p:nvSpPr>
-          <p:cNvPr id="3" name="Date Placeholder 2"/>
-          <p:cNvSpPr>
-            <a:spLocks noGrp="1"/>
-          </p:cNvSpPr>
-          <p:nvPr>
-            <p:ph type="dt" idx="1"/>
-          </p:nvPr>
-        </p:nvSpPr>
-        <p:spPr>
-          <a:xfrm>
-            <a:off x="3884613" y="0"/>
-            <a:ext cx="2971800" cy="458788"/>
-          </a:xfrm>
-          <a:prstGeom prst="rect">
-            <a:avLst/>
-          </a:prstGeom>
-        </p:spPr>
-        <p:txBody>
-          <a:bodyPr vert="horz" lIns="91440" tIns="45720" rIns="91440" bIns="45720" rtlCol="0"/>
-          <a:lstStyle>
-            <a:lvl1pPr algn="r">
-              <a:defRPr sz="1200"/>
-            </a:lvl1pPr>
-          </a:lstStyle>
-          <a:p>
-            <a:fld id="{5282F153-3F37-0F45-9E97-73ACFA13230C}" type="datetimeFigureOut">
-              <a:rPr lang="en-US"/>
-              <a:t>7/23/19</a:t>
-            </a:fld>
-            <a:endParaRPr lang="en-US"/>
-          </a:p>
-        </p:txBody>
-      </p:sp>
-      <p:sp>
-        <p:nvSpPr>
-          <p:cNvPr id="4" name="Slide Image Placeholder 3"/>
-          <p:cNvSpPr>
-            <a:spLocks noGrp="1" noRot="1" noChangeAspect="1"/>
-          </p:cNvSpPr>
-          <p:nvPr>
-            <p:ph type="sldImg" idx="2"/>
-          </p:nvPr>
-        </p:nvSpPr>
-        <p:spPr>
-          <a:xfrm>
-            <a:off x="685800" y="1143000"/>
-            <a:ext cx="5486400" cy="3086100"/>
-          </a:xfrm>
-          <a:prstGeom prst="rect">
-            <a:avLst/>
-          </a:prstGeom>
-          <a:noFill/>
-          <a:ln w="12700">
-            <a:solidFill>
-              <a:prstClr val="black"/>
-            </a:solidFill>
-          </a:ln>
-        </p:spPr>
-        <p:txBody>
-          <a:bodyPr vert="horz" lIns="91440" tIns="45720" rIns="91440" bIns="45720" rtlCol="0" anchor="ctr"/>
-          <a:lstStyle/>
-          <a:p>
-            <a:endParaRPr lang="en-US"/>
-          </a:p>
-        </p:txBody>
-      </p:sp>
-      <p:sp>
-        <p:nvSpPr>
-          <p:cNvPr id="5" name="Notes Placeholder 4"/>
-          <p:cNvSpPr>
-            <a:spLocks noGrp="1"/>
-          </p:cNvSpPr>
-          <p:nvPr>
-            <p:ph type="body" sz="quarter" idx="3"/>
-          </p:nvPr>
-        </p:nvSpPr>
-        <p:spPr>
-          <a:xfrm>
-            <a:off x="685800" y="4400550"/>
-            <a:ext cx="5486400" cy="3600450"/>
-          </a:xfrm>
-          <a:prstGeom prst="rect">
-            <a:avLst/>
-          </a:prstGeom>
-        </p:spPr>
-        <p:txBody>
-          <a:bodyPr vert="horz" lIns="91440" tIns="45720" rIns="91440" bIns="45720" rtlCol="0"/>
-          <a:lstStyle/>
-          <a:p>
-            <a:pPr lvl="0"/>
-            <a:r>
-              <a:rPr lang="en-US"/>
-              <a:t>Click to edit Master text styles</a:t>
-            </a:r>
-          </a:p>
-          <a:p>
-            <a:pPr lvl="1"/>
-            <a:r>
-              <a:rPr lang="en-US"/>
-              <a:t>Second level</a:t>
-            </a:r>
-          </a:p>
-          <a:p>
-            <a:pPr lvl="2"/>
-            <a:r>
-              <a:rPr lang="en-US"/>
-              <a:t>Third level</a:t>
-            </a:r>
-          </a:p>
-          <a:p>
-            <a:pPr lvl="3"/>
-            <a:r>
-              <a:rPr lang="en-US"/>
-              <a:t>Fourth level</a:t>
-            </a:r>
-          </a:p>
-          <a:p>
-            <a:pPr lvl="4"/>
-            <a:r>
-              <a:rPr lang="en-US"/>
-              <a:t>Fifth level</a:t>
-            </a:r>
-          </a:p>
-        </p:txBody>
-      </p:sp>
-      <p:sp>
-        <p:nvSpPr>
-          <p:cNvPr id="6" name="Footer Placeholder 5"/>
-          <p:cNvSpPr>
-            <a:spLocks noGrp="1"/>
-          </p:cNvSpPr>
-          <p:nvPr>
-            <p:ph type="ftr" sz="quarter" idx="4"/>
-          </p:nvPr>
-        </p:nvSpPr>
-        <p:spPr>
-          <a:xfrm>
-            <a:off x="0" y="8685213"/>
-            <a:ext cx="2971800" cy="458787"/>
-          </a:xfrm>
-          <a:prstGeom prst="rect">
-            <a:avLst/>
-          </a:prstGeom>
-        </p:spPr>
-        <p:txBody>
-          <a:bodyPr vert="horz" lIns="91440" tIns="45720" rIns="91440" bIns="45720" rtlCol="0" anchor="b"/>
-          <a:lstStyle>
-            <a:lvl1pPr algn="l">
-              <a:defRPr sz="1200"/>
-            </a:lvl1pPr>
-          </a:lstStyle>
-          <a:p>
-            <a:endParaRPr lang="en-US"/>
-          </a:p>
-        </p:txBody>
-      </p:sp>
-      <p:sp>
-        <p:nvSpPr>
-          <p:cNvPr id="7" name="Slide Number Placeholder 6"/>
-          <p:cNvSpPr>
-            <a:spLocks noGrp="1"/>
-          </p:cNvSpPr>
-          <p:nvPr>
-            <p:ph type="sldNum" sz="quarter" idx="5"/>
-          </p:nvPr>
-        </p:nvSpPr>
-        <p:spPr>
-          <a:xfrm>
-            <a:off x="3884613" y="8685213"/>
-            <a:ext cx="2971800" cy="458787"/>
-          </a:xfrm>
-          <a:prstGeom prst="rect">
-            <a:avLst/>
-          </a:prstGeom>
-        </p:spPr>
-        <p:txBody>
-          <a:bodyPr vert="horz" lIns="91440" tIns="45720" rIns="91440" bIns="45720" rtlCol="0" anchor="b"/>
-          <a:lstStyle>
-            <a:lvl1pPr algn="r">
-              <a:defRPr sz="1200"/>
-            </a:lvl1pPr>
-          </a:lstStyle>
-          <a:p>
-            <a:fld id="{CE5E9CC1-C706-0F49-92D6-E571CC5EEA8F}" type="slidenum">
-              <a:rPr lang="en-US"/>
-              <a:t>‹#›</a:t>
-            </a:fld>
-            <a:endParaRPr lang="en-US"/>
-          </a:p>
-        </p:txBody>
-      </p:sp>
     </p:spTree>
     <p:extLst>
       <p:ext uri="{BB962C8B-B14F-4D97-AF65-F5344CB8AC3E}">
-        <p14:creationId xmlns:p14="http://schemas.microsoft.com/office/powerpoint/2010/main" val="1024086991"/>
+        <p14:creationId xmlns:p14="http://schemas.microsoft.com/office/powerpoint/2010/main" val="3673717257"/>
       </p:ext>
     </p:extLst>
   </p:cSld>
@@ -769,10 +552,6 @@
           <a:bodyPr/>
           <a:lstStyle/>
           <a:p>
-            <a:r>
-              <a:rPr lang="en-US" dirty="0"/>
-              <a:t/>
-            </a:r>
             <a:endParaRPr lang="en-US" dirty="0"/>
           </a:p>
         </p:txBody>
@@ -857,10 +636,6 @@
           <a:bodyPr/>
           <a:lstStyle/>
           <a:p>
-            <a:r>
-              <a:rPr lang="en-US" dirty="0"/>
-              <a:t/>
-            </a:r>
             <a:endParaRPr lang="en-US" dirty="0"/>
           </a:p>
         </p:txBody>
@@ -945,10 +720,6 @@
           <a:bodyPr/>
           <a:lstStyle/>
           <a:p>
-            <a:r>
-              <a:rPr lang="en-US" dirty="0"/>
-              <a:t/>
-            </a:r>
             <a:endParaRPr lang="en-US" dirty="0"/>
           </a:p>
         </p:txBody>
@@ -1033,10 +804,6 @@
           <a:bodyPr/>
           <a:lstStyle/>
           <a:p>
-            <a:r>
-              <a:rPr lang="en-US" dirty="0"/>
-              <a:t/>
-            </a:r>
             <a:endParaRPr lang="en-US" dirty="0"/>
           </a:p>
         </p:txBody>
@@ -1121,10 +888,6 @@
           <a:bodyPr/>
           <a:lstStyle/>
           <a:p>
-            <a:r>
-              <a:rPr lang="en-US" dirty="0"/>
-              <a:t/>
-            </a:r>
             <a:endParaRPr lang="en-US" dirty="0"/>
           </a:p>
         </p:txBody>
@@ -1209,10 +972,6 @@
           <a:bodyPr/>
           <a:lstStyle/>
           <a:p>
-            <a:r>
-              <a:rPr lang="en-US" dirty="0"/>
-              <a:t/>
-            </a:r>
             <a:endParaRPr lang="en-US" dirty="0"/>
           </a:p>
         </p:txBody>
@@ -1297,10 +1056,6 @@
           <a:bodyPr/>
           <a:lstStyle/>
           <a:p>
-            <a:r>
-              <a:rPr lang="en-US" dirty="0"/>
-              <a:t/>
-            </a:r>
             <a:endParaRPr lang="en-US" dirty="0"/>
           </a:p>
         </p:txBody>
@@ -1385,10 +1140,6 @@
           <a:bodyPr/>
           <a:lstStyle/>
           <a:p>
-            <a:r>
-              <a:rPr lang="en-US" dirty="0"/>
-              <a:t/>
-            </a:r>
             <a:endParaRPr lang="en-US" dirty="0"/>
           </a:p>
         </p:txBody>
@@ -1473,10 +1224,6 @@
           <a:bodyPr/>
           <a:lstStyle/>
           <a:p>
-            <a:r>
-              <a:rPr lang="en-US" dirty="0"/>
-              <a:t/>
-            </a:r>
             <a:endParaRPr lang="en-US" dirty="0"/>
           </a:p>
         </p:txBody>
@@ -1561,10 +1308,6 @@
           <a:bodyPr/>
           <a:lstStyle/>
           <a:p>
-            <a:r>
-              <a:rPr lang="en-US" dirty="0"/>
-              <a:t/>
-            </a:r>
             <a:endParaRPr lang="en-US" dirty="0"/>
           </a:p>
         </p:txBody>
@@ -1649,10 +1392,6 @@
           <a:bodyPr/>
           <a:lstStyle/>
           <a:p>
-            <a:r>
-              <a:rPr lang="en-US" dirty="0"/>
-              <a:t/>
-            </a:r>
             <a:endParaRPr lang="en-US" dirty="0"/>
           </a:p>
         </p:txBody>
@@ -1737,10 +1476,6 @@
           <a:bodyPr/>
           <a:lstStyle/>
           <a:p>
-            <a:r>
-              <a:rPr lang="en-US" dirty="0"/>
-              <a:t/>
-            </a:r>
             <a:endParaRPr lang="en-US" dirty="0"/>
           </a:p>
         </p:txBody>
@@ -1825,10 +1560,6 @@
           <a:bodyPr/>
           <a:lstStyle/>
           <a:p>
-            <a:r>
-              <a:rPr lang="en-US" dirty="0"/>
-              <a:t/>
-            </a:r>
             <a:endParaRPr lang="en-US" dirty="0"/>
           </a:p>
         </p:txBody>
@@ -1913,10 +1644,6 @@
           <a:bodyPr/>
           <a:lstStyle/>
           <a:p>
-            <a:r>
-              <a:rPr lang="en-US" dirty="0"/>
-              <a:t/>
-            </a:r>
             <a:endParaRPr lang="en-US" dirty="0"/>
           </a:p>
         </p:txBody>
@@ -1990,6 +1717,11 @@
 <file path=ppt/slideMasters/slideMaster1.xml><?xml version="1.0" encoding="utf-8"?>
 <p:sldMaster xmlns:a="http://schemas.openxmlformats.org/drawingml/2006/main" xmlns:r="http://schemas.openxmlformats.org/officeDocument/2006/relationships" xmlns:p="http://schemas.openxmlformats.org/presentationml/2006/main">
   <p:cSld>
+    <p:bg>
+      <p:bgRef idx="1001">
+        <a:schemeClr val="bg1"/>
+      </p:bgRef>
+    </p:bg>
     <p:spTree>
       <p:nvGrpSpPr>
         <p:cNvPr id="1" name=""/>
@@ -2272,6 +2004,7 @@
         <a:solidFill>
           <a:srgbClr val="1B2A3A"/>
         </a:solidFill>
+        <a:effectLst/>
       </p:bgPr>
     </p:bg>
     <p:spTree>
@@ -2329,11 +2062,11 @@
           <a:bodyPr wrap="square" lIns="0" tIns="0" rIns="0" bIns="0" rtlCol="0" anchor="ctr"/>
           <a:lstStyle/>
           <a:p>
-            <a:pPr indent="0" marL="0">
-              <a:buNone/>
-            </a:pPr>
-            <a:r>
-              <a:rPr lang="en-US" sz="1200" b="1" spc="200" kern="0" dirty="0">
+            <a:pPr marL="0" indent="0">
+              <a:buNone/>
+            </a:pPr>
+            <a:r>
+              <a:rPr lang="en-US" sz="1200" b="1" kern="0" spc="200" dirty="0">
                 <a:solidFill>
                   <a:srgbClr val="8FB4DC"/>
                 </a:solidFill>
@@ -2368,7 +2101,7 @@
           <a:bodyPr wrap="square" lIns="0" tIns="0" rIns="0" bIns="0" rtlCol="0" anchor="ctr"/>
           <a:lstStyle/>
           <a:p>
-            <a:pPr indent="0" marL="0">
+            <a:pPr marL="0" indent="0">
               <a:buNone/>
             </a:pPr>
             <a:r>
@@ -2407,7 +2140,7 @@
           <a:bodyPr wrap="square" lIns="0" tIns="0" rIns="0" bIns="0" rtlCol="0" anchor="ctr"/>
           <a:lstStyle/>
           <a:p>
-            <a:pPr indent="0" marL="0">
+            <a:pPr marL="0" indent="0">
               <a:buNone/>
             </a:pPr>
             <a:r>
@@ -2446,7 +2179,7 @@
           <a:bodyPr wrap="square" lIns="0" tIns="0" rIns="0" bIns="0" rtlCol="0" anchor="ctr"/>
           <a:lstStyle/>
           <a:p>
-            <a:pPr indent="0" marL="0">
+            <a:pPr marL="0" indent="0">
               <a:buNone/>
             </a:pPr>
             <a:r>
@@ -2460,9 +2193,6 @@
               </a:rPr>
               <a:t>A System of Action</a:t>
             </a:r>
-            <a:pPr indent="0" marL="0">
-              <a:buNone/>
-            </a:pPr>
             <a:r>
               <a:rPr lang="en-US" sz="1400" dirty="0">
                 <a:solidFill>
@@ -2579,7 +2309,7 @@
           <a:bodyPr wrap="square" lIns="0" tIns="0" rIns="0" bIns="0" rtlCol="0" anchor="ctr"/>
           <a:lstStyle/>
           <a:p>
-            <a:pPr indent="0" marL="0">
+            <a:pPr marL="0" indent="0">
               <a:buNone/>
             </a:pPr>
             <a:r>
@@ -2618,7 +2348,7 @@
           <a:bodyPr wrap="square" lIns="0" tIns="0" rIns="0" bIns="0" rtlCol="0" anchor="ctr"/>
           <a:lstStyle/>
           <a:p>
-            <a:pPr indent="0" marL="0">
+            <a:pPr marL="0" indent="0">
               <a:buNone/>
             </a:pPr>
             <a:r>
@@ -2652,6 +2382,7 @@
         <a:solidFill>
           <a:srgbClr val="FFFFFF"/>
         </a:solidFill>
+        <a:effectLst/>
       </p:bgPr>
     </p:bg>
     <p:spTree>
@@ -2689,11 +2420,11 @@
           <a:bodyPr wrap="square" lIns="0" tIns="0" rIns="0" bIns="0" rtlCol="0" anchor="ctr"/>
           <a:lstStyle/>
           <a:p>
-            <a:pPr indent="0" marL="0">
-              <a:buNone/>
-            </a:pPr>
-            <a:r>
-              <a:rPr lang="en-US" sz="1100" b="1" spc="200" kern="0" dirty="0">
+            <a:pPr marL="0" indent="0">
+              <a:buNone/>
+            </a:pPr>
+            <a:r>
+              <a:rPr lang="en-US" sz="1100" b="1" kern="0" spc="200" dirty="0">
                 <a:solidFill>
                   <a:srgbClr val="2B6CB0"/>
                 </a:solidFill>
@@ -2728,7 +2459,7 @@
           <a:bodyPr wrap="square" lIns="0" tIns="0" rIns="0" bIns="0" rtlCol="0" anchor="ctr"/>
           <a:lstStyle/>
           <a:p>
-            <a:pPr indent="0" marL="0">
+            <a:pPr marL="0" indent="0">
               <a:buNone/>
             </a:pPr>
             <a:r>
@@ -2762,16 +2493,34 @@
         </p:nvGraphicFramePr>
         <p:xfrm>
           <a:off x="457200" y="1371600"/>
-          <a:ext cx="8229600" cy="914400"/>
+          <a:ext cx="8229600" cy="2724912"/>
         </p:xfrm>
         <a:graphic>
           <a:graphicData uri="http://schemas.openxmlformats.org/drawingml/2006/table">
             <a:tbl>
               <a:tblPr/>
               <a:tblGrid>
-                <a:gridCol w="1737360"/>
-                <a:gridCol w="3246120"/>
-                <a:gridCol w="3246120"/>
+                <a:gridCol w="1737360">
+                  <a:extLst>
+                    <a:ext uri="{9D8B030D-6E8A-4147-A177-3AD203B41FA5}">
+                      <a16:colId xmlns:a16="http://schemas.microsoft.com/office/drawing/2014/main" val="20000"/>
+                    </a:ext>
+                  </a:extLst>
+                </a:gridCol>
+                <a:gridCol w="3246120">
+                  <a:extLst>
+                    <a:ext uri="{9D8B030D-6E8A-4147-A177-3AD203B41FA5}">
+                      <a16:colId xmlns:a16="http://schemas.microsoft.com/office/drawing/2014/main" val="20001"/>
+                    </a:ext>
+                  </a:extLst>
+                </a:gridCol>
+                <a:gridCol w="3246120">
+                  <a:extLst>
+                    <a:ext uri="{9D8B030D-6E8A-4147-A177-3AD203B41FA5}">
+                      <a16:colId xmlns:a16="http://schemas.microsoft.com/office/drawing/2014/main" val="20002"/>
+                    </a:ext>
+                  </a:extLst>
+                </a:gridCol>
               </a:tblGrid>
               <a:tr h="457200">
                 <a:tc>
@@ -2779,7 +2528,7 @@
                     <a:bodyPr/>
                     <a:lstStyle/>
                     <a:p>
-                      <a:pPr algn="l" indent="0" marL="0">
+                      <a:pPr marL="0" indent="0" algn="l">
                         <a:buNone/>
                       </a:pPr>
                       <a:r>
@@ -2800,7 +2549,7 @@
                       </a:endParaRPr>
                     </a:p>
                   </a:txBody>
-                  <a:tcPr marL="91440" marR="91440" marT="45720" marB="45720" anchor="ctr">
+                  <a:tcPr anchor="ctr">
                     <a:lnL w="12700" cap="flat" cmpd="sng" algn="ctr">
                       <a:solidFill>
                         <a:srgbClr val="CBD5E1"/>
@@ -2847,7 +2596,7 @@
                     <a:bodyPr/>
                     <a:lstStyle/>
                     <a:p>
-                      <a:pPr algn="l" indent="0" marL="0">
+                      <a:pPr marL="0" indent="0" algn="l">
                         <a:buNone/>
                       </a:pPr>
                       <a:r>
@@ -2868,7 +2617,7 @@
                       </a:endParaRPr>
                     </a:p>
                   </a:txBody>
-                  <a:tcPr marL="91440" marR="91440" marT="45720" marB="45720" anchor="ctr">
+                  <a:tcPr anchor="ctr">
                     <a:lnL w="12700" cap="flat" cmpd="sng" algn="ctr">
                       <a:solidFill>
                         <a:srgbClr val="CBD5E1"/>
@@ -2915,7 +2664,7 @@
                     <a:bodyPr/>
                     <a:lstStyle/>
                     <a:p>
-                      <a:pPr algn="l" indent="0" marL="0">
+                      <a:pPr marL="0" indent="0" algn="l">
                         <a:buNone/>
                       </a:pPr>
                       <a:r>
@@ -2936,7 +2685,7 @@
                       </a:endParaRPr>
                     </a:p>
                   </a:txBody>
-                  <a:tcPr marL="91440" marR="91440" marT="45720" marB="45720" anchor="ctr">
+                  <a:tcPr anchor="ctr">
                     <a:lnL w="12700" cap="flat" cmpd="sng" algn="ctr">
                       <a:solidFill>
                         <a:srgbClr val="CBD5E1"/>
@@ -2978,6 +2727,11 @@
                     </a:solidFill>
                   </a:tcPr>
                 </a:tc>
+                <a:extLst>
+                  <a:ext uri="{0D108BD9-81ED-4DB2-BD59-A6C34878D82A}">
+                    <a16:rowId xmlns:a16="http://schemas.microsoft.com/office/drawing/2014/main" val="10000"/>
+                  </a:ext>
+                </a:extLst>
               </a:tr>
               <a:tr h="566928">
                 <a:tc>
@@ -2985,7 +2739,7 @@
                     <a:bodyPr/>
                     <a:lstStyle/>
                     <a:p>
-                      <a:pPr algn="l" indent="0" marL="0">
+                      <a:pPr marL="0" indent="0" algn="l">
                         <a:buNone/>
                       </a:pPr>
                       <a:r>
@@ -3006,7 +2760,7 @@
                       </a:endParaRPr>
                     </a:p>
                   </a:txBody>
-                  <a:tcPr marL="91440" marR="91440" marT="45720" marB="45720" anchor="ctr">
+                  <a:tcPr anchor="ctr">
                     <a:lnL w="12700" cap="flat" cmpd="sng" algn="ctr">
                       <a:solidFill>
                         <a:srgbClr val="CBD5E1"/>
@@ -3053,7 +2807,7 @@
                     <a:bodyPr/>
                     <a:lstStyle/>
                     <a:p>
-                      <a:pPr algn="l" indent="0" marL="0">
+                      <a:pPr marL="0" indent="0" algn="l">
                         <a:buNone/>
                       </a:pPr>
                       <a:r>
@@ -3074,7 +2828,7 @@
                       </a:endParaRPr>
                     </a:p>
                   </a:txBody>
-                  <a:tcPr marL="91440" marR="91440" marT="45720" marB="45720" anchor="ctr">
+                  <a:tcPr anchor="ctr">
                     <a:lnL w="12700" cap="flat" cmpd="sng" algn="ctr">
                       <a:solidFill>
                         <a:srgbClr val="CBD5E1"/>
@@ -3121,7 +2875,7 @@
                     <a:bodyPr/>
                     <a:lstStyle/>
                     <a:p>
-                      <a:pPr algn="l" indent="0" marL="0">
+                      <a:pPr marL="0" indent="0" algn="l">
                         <a:buNone/>
                       </a:pPr>
                       <a:r>
@@ -3142,7 +2896,7 @@
                       </a:endParaRPr>
                     </a:p>
                   </a:txBody>
-                  <a:tcPr marL="91440" marR="91440" marT="45720" marB="45720" anchor="ctr">
+                  <a:tcPr anchor="ctr">
                     <a:lnL w="12700" cap="flat" cmpd="sng" algn="ctr">
                       <a:solidFill>
                         <a:srgbClr val="CBD5E1"/>
@@ -3184,6 +2938,11 @@
                     </a:solidFill>
                   </a:tcPr>
                 </a:tc>
+                <a:extLst>
+                  <a:ext uri="{0D108BD9-81ED-4DB2-BD59-A6C34878D82A}">
+                    <a16:rowId xmlns:a16="http://schemas.microsoft.com/office/drawing/2014/main" val="10001"/>
+                  </a:ext>
+                </a:extLst>
               </a:tr>
               <a:tr h="566928">
                 <a:tc>
@@ -3191,7 +2950,7 @@
                     <a:bodyPr/>
                     <a:lstStyle/>
                     <a:p>
-                      <a:pPr algn="l" indent="0" marL="0">
+                      <a:pPr marL="0" indent="0" algn="l">
                         <a:buNone/>
                       </a:pPr>
                       <a:r>
@@ -3212,7 +2971,7 @@
                       </a:endParaRPr>
                     </a:p>
                   </a:txBody>
-                  <a:tcPr marL="91440" marR="91440" marT="45720" marB="45720" anchor="ctr">
+                  <a:tcPr anchor="ctr">
                     <a:lnL w="12700" cap="flat" cmpd="sng" algn="ctr">
                       <a:solidFill>
                         <a:srgbClr val="CBD5E1"/>
@@ -3259,7 +3018,7 @@
                     <a:bodyPr/>
                     <a:lstStyle/>
                     <a:p>
-                      <a:pPr algn="l" indent="0" marL="0">
+                      <a:pPr marL="0" indent="0" algn="l">
                         <a:buNone/>
                       </a:pPr>
                       <a:r>
@@ -3280,7 +3039,7 @@
                       </a:endParaRPr>
                     </a:p>
                   </a:txBody>
-                  <a:tcPr marL="91440" marR="91440" marT="45720" marB="45720" anchor="ctr">
+                  <a:tcPr anchor="ctr">
                     <a:lnL w="12700" cap="flat" cmpd="sng" algn="ctr">
                       <a:solidFill>
                         <a:srgbClr val="CBD5E1"/>
@@ -3327,7 +3086,7 @@
                     <a:bodyPr/>
                     <a:lstStyle/>
                     <a:p>
-                      <a:pPr algn="l" indent="0" marL="0">
+                      <a:pPr marL="0" indent="0" algn="l">
                         <a:buNone/>
                       </a:pPr>
                       <a:r>
@@ -3348,7 +3107,7 @@
                       </a:endParaRPr>
                     </a:p>
                   </a:txBody>
-                  <a:tcPr marL="91440" marR="91440" marT="45720" marB="45720" anchor="ctr">
+                  <a:tcPr anchor="ctr">
                     <a:lnL w="12700" cap="flat" cmpd="sng" algn="ctr">
                       <a:solidFill>
                         <a:srgbClr val="CBD5E1"/>
@@ -3390,6 +3149,11 @@
                     </a:solidFill>
                   </a:tcPr>
                 </a:tc>
+                <a:extLst>
+                  <a:ext uri="{0D108BD9-81ED-4DB2-BD59-A6C34878D82A}">
+                    <a16:rowId xmlns:a16="http://schemas.microsoft.com/office/drawing/2014/main" val="10002"/>
+                  </a:ext>
+                </a:extLst>
               </a:tr>
               <a:tr h="566928">
                 <a:tc>
@@ -3397,7 +3161,7 @@
                     <a:bodyPr/>
                     <a:lstStyle/>
                     <a:p>
-                      <a:pPr algn="l" indent="0" marL="0">
+                      <a:pPr marL="0" indent="0" algn="l">
                         <a:buNone/>
                       </a:pPr>
                       <a:r>
@@ -3418,7 +3182,7 @@
                       </a:endParaRPr>
                     </a:p>
                   </a:txBody>
-                  <a:tcPr marL="91440" marR="91440" marT="45720" marB="45720" anchor="ctr">
+                  <a:tcPr anchor="ctr">
                     <a:lnL w="12700" cap="flat" cmpd="sng" algn="ctr">
                       <a:solidFill>
                         <a:srgbClr val="CBD5E1"/>
@@ -3465,7 +3229,7 @@
                     <a:bodyPr/>
                     <a:lstStyle/>
                     <a:p>
-                      <a:pPr algn="l" indent="0" marL="0">
+                      <a:pPr marL="0" indent="0" algn="l">
                         <a:buNone/>
                       </a:pPr>
                       <a:r>
@@ -3486,7 +3250,7 @@
                       </a:endParaRPr>
                     </a:p>
                   </a:txBody>
-                  <a:tcPr marL="91440" marR="91440" marT="45720" marB="45720" anchor="ctr">
+                  <a:tcPr anchor="ctr">
                     <a:lnL w="12700" cap="flat" cmpd="sng" algn="ctr">
                       <a:solidFill>
                         <a:srgbClr val="CBD5E1"/>
@@ -3533,7 +3297,7 @@
                     <a:bodyPr/>
                     <a:lstStyle/>
                     <a:p>
-                      <a:pPr algn="l" indent="0" marL="0">
+                      <a:pPr marL="0" indent="0" algn="l">
                         <a:buNone/>
                       </a:pPr>
                       <a:r>
@@ -3554,7 +3318,7 @@
                       </a:endParaRPr>
                     </a:p>
                   </a:txBody>
-                  <a:tcPr marL="91440" marR="91440" marT="45720" marB="45720" anchor="ctr">
+                  <a:tcPr anchor="ctr">
                     <a:lnL w="12700" cap="flat" cmpd="sng" algn="ctr">
                       <a:solidFill>
                         <a:srgbClr val="CBD5E1"/>
@@ -3596,6 +3360,11 @@
                     </a:solidFill>
                   </a:tcPr>
                 </a:tc>
+                <a:extLst>
+                  <a:ext uri="{0D108BD9-81ED-4DB2-BD59-A6C34878D82A}">
+                    <a16:rowId xmlns:a16="http://schemas.microsoft.com/office/drawing/2014/main" val="10003"/>
+                  </a:ext>
+                </a:extLst>
               </a:tr>
               <a:tr h="566928">
                 <a:tc>
@@ -3603,7 +3372,7 @@
                     <a:bodyPr/>
                     <a:lstStyle/>
                     <a:p>
-                      <a:pPr algn="l" indent="0" marL="0">
+                      <a:pPr marL="0" indent="0" algn="l">
                         <a:buNone/>
                       </a:pPr>
                       <a:r>
@@ -3624,7 +3393,7 @@
                       </a:endParaRPr>
                     </a:p>
                   </a:txBody>
-                  <a:tcPr marL="91440" marR="91440" marT="45720" marB="45720" anchor="ctr">
+                  <a:tcPr anchor="ctr">
                     <a:lnL w="12700" cap="flat" cmpd="sng" algn="ctr">
                       <a:solidFill>
                         <a:srgbClr val="CBD5E1"/>
@@ -3671,7 +3440,7 @@
                     <a:bodyPr/>
                     <a:lstStyle/>
                     <a:p>
-                      <a:pPr algn="l" indent="0" marL="0">
+                      <a:pPr marL="0" indent="0" algn="l">
                         <a:buNone/>
                       </a:pPr>
                       <a:r>
@@ -3692,7 +3461,7 @@
                       </a:endParaRPr>
                     </a:p>
                   </a:txBody>
-                  <a:tcPr marL="91440" marR="91440" marT="45720" marB="45720" anchor="ctr">
+                  <a:tcPr anchor="ctr">
                     <a:lnL w="12700" cap="flat" cmpd="sng" algn="ctr">
                       <a:solidFill>
                         <a:srgbClr val="CBD5E1"/>
@@ -3739,7 +3508,7 @@
                     <a:bodyPr/>
                     <a:lstStyle/>
                     <a:p>
-                      <a:pPr algn="l" indent="0" marL="0">
+                      <a:pPr marL="0" indent="0" algn="l">
                         <a:buNone/>
                       </a:pPr>
                       <a:r>
@@ -3760,7 +3529,7 @@
                       </a:endParaRPr>
                     </a:p>
                   </a:txBody>
-                  <a:tcPr marL="91440" marR="91440" marT="45720" marB="45720" anchor="ctr">
+                  <a:tcPr anchor="ctr">
                     <a:lnL w="12700" cap="flat" cmpd="sng" algn="ctr">
                       <a:solidFill>
                         <a:srgbClr val="CBD5E1"/>
@@ -3802,6 +3571,11 @@
                     </a:solidFill>
                   </a:tcPr>
                 </a:tc>
+                <a:extLst>
+                  <a:ext uri="{0D108BD9-81ED-4DB2-BD59-A6C34878D82A}">
+                    <a16:rowId xmlns:a16="http://schemas.microsoft.com/office/drawing/2014/main" val="10004"/>
+                  </a:ext>
+                </a:extLst>
               </a:tr>
             </a:tbl>
           </a:graphicData>
@@ -3848,7 +3622,7 @@
           <a:bodyPr wrap="square" lIns="0" tIns="0" rIns="0" bIns="0" rtlCol="0" anchor="ctr"/>
           <a:lstStyle/>
           <a:p>
-            <a:pPr indent="0" marL="0">
+            <a:pPr marL="0" indent="0">
               <a:buNone/>
             </a:pPr>
             <a:r>
@@ -3862,9 +3636,6 @@
               </a:rPr>
               <a:t>Layer</a:t>
             </a:r>
-            <a:pPr indent="0" marL="0">
-              <a:buNone/>
-            </a:pPr>
             <a:endParaRPr lang="en-US" sz="1300" dirty="0"/>
           </a:p>
         </p:txBody>
@@ -3890,7 +3661,7 @@
           <a:bodyPr wrap="square" lIns="0" tIns="0" rIns="0" bIns="0" rtlCol="0" anchor="ctr"/>
           <a:lstStyle/>
           <a:p>
-            <a:pPr indent="0" marL="0">
+            <a:pPr marL="0" indent="0">
               <a:buNone/>
             </a:pPr>
             <a:r>
@@ -3929,7 +3700,7 @@
           <a:bodyPr wrap="square" lIns="0" tIns="0" rIns="0" bIns="0" rtlCol="0" anchor="ctr"/>
           <a:lstStyle/>
           <a:p>
-            <a:pPr indent="0" marL="0">
+            <a:pPr marL="0" indent="0">
               <a:buNone/>
             </a:pPr>
             <a:r>
@@ -3973,7 +3744,7 @@
             <a:prstDash val="solid"/>
           </a:ln>
           <a:effectLst>
-            <a:outerShdw sx="100000" sy="100000" kx="0" ky="0" algn="bl" rotWithShape="0" blurRad="88900" dist="25400" dir="8100000">
+            <a:outerShdw blurRad="88900" dist="25400" dir="8100000" algn="bl" rotWithShape="0">
               <a:srgbClr val="1B2A3A">
                 <a:alpha val="13000"/>
               </a:srgbClr>
@@ -4002,7 +3773,7 @@
           <a:bodyPr wrap="square" lIns="0" tIns="0" rIns="0" bIns="0" rtlCol="0" anchor="ctr"/>
           <a:lstStyle/>
           <a:p>
-            <a:pPr indent="0" marL="0">
+            <a:pPr marL="0" indent="0">
               <a:buNone/>
             </a:pPr>
             <a:r>
@@ -4016,9 +3787,6 @@
               </a:rPr>
               <a:t>The deterministic path is also the reproducible baseline the eval judges score against — </a:t>
             </a:r>
-            <a:pPr indent="0" marL="0">
-              <a:buNone/>
-            </a:pPr>
             <a:r>
               <a:rPr lang="en-US" sz="1250" b="1" dirty="0">
                 <a:solidFill>
@@ -4050,6 +3818,7 @@
         <a:solidFill>
           <a:srgbClr val="FFFFFF"/>
         </a:solidFill>
+        <a:effectLst/>
       </p:bgPr>
     </p:bg>
     <p:spTree>
@@ -4087,11 +3856,11 @@
           <a:bodyPr wrap="square" lIns="0" tIns="0" rIns="0" bIns="0" rtlCol="0" anchor="ctr"/>
           <a:lstStyle/>
           <a:p>
-            <a:pPr indent="0" marL="0">
-              <a:buNone/>
-            </a:pPr>
-            <a:r>
-              <a:rPr lang="en-US" sz="1100" b="1" spc="200" kern="0" dirty="0">
+            <a:pPr marL="0" indent="0">
+              <a:buNone/>
+            </a:pPr>
+            <a:r>
+              <a:rPr lang="en-US" sz="1100" b="1" kern="0" spc="200" dirty="0">
                 <a:solidFill>
                   <a:srgbClr val="2B6CB0"/>
                 </a:solidFill>
@@ -4126,7 +3895,7 @@
           <a:bodyPr wrap="square" lIns="0" tIns="0" rIns="0" bIns="0" rtlCol="0" anchor="ctr"/>
           <a:lstStyle/>
           <a:p>
-            <a:pPr indent="0" marL="0">
+            <a:pPr marL="0" indent="0">
               <a:buNone/>
             </a:pPr>
             <a:r>
@@ -4170,7 +3939,7 @@
             <a:prstDash val="solid"/>
           </a:ln>
           <a:effectLst>
-            <a:outerShdw sx="100000" sy="100000" kx="0" ky="0" algn="bl" rotWithShape="0" blurRad="88900" dist="25400" dir="8100000">
+            <a:outerShdw blurRad="88900" dist="25400" dir="8100000" algn="bl" rotWithShape="0">
               <a:srgbClr val="1B2A3A">
                 <a:alpha val="13000"/>
               </a:srgbClr>
@@ -4219,7 +3988,7 @@
           <a:bodyPr wrap="square" lIns="0" tIns="0" rIns="0" bIns="0" rtlCol="0" anchor="ctr"/>
           <a:lstStyle/>
           <a:p>
-            <a:pPr algn="ctr" indent="0" marL="0">
+            <a:pPr marL="0" indent="0" algn="ctr">
               <a:buNone/>
             </a:pPr>
             <a:r>
@@ -4258,7 +4027,7 @@
           <a:bodyPr wrap="square" lIns="0" tIns="0" rIns="0" bIns="0" rtlCol="0" anchor="ctr"/>
           <a:lstStyle/>
           <a:p>
-            <a:pPr indent="0" marL="0">
+            <a:pPr marL="0" indent="0">
               <a:buNone/>
             </a:pPr>
             <a:r>
@@ -4297,7 +4066,7 @@
           <a:bodyPr wrap="square" lIns="0" tIns="0" rIns="0" bIns="0" rtlCol="0" anchor="ctr"/>
           <a:lstStyle/>
           <a:p>
-            <a:pPr indent="0" marL="0">
+            <a:pPr marL="0" indent="0">
               <a:lnSpc>
                 <a:spcPct val="105000"/>
               </a:lnSpc>
@@ -4344,7 +4113,7 @@
             <a:prstDash val="solid"/>
           </a:ln>
           <a:effectLst>
-            <a:outerShdw sx="100000" sy="100000" kx="0" ky="0" algn="bl" rotWithShape="0" blurRad="88900" dist="25400" dir="8100000">
+            <a:outerShdw blurRad="88900" dist="25400" dir="8100000" algn="bl" rotWithShape="0">
               <a:srgbClr val="1B2A3A">
                 <a:alpha val="13000"/>
               </a:srgbClr>
@@ -4393,7 +4162,7 @@
           <a:bodyPr wrap="square" lIns="0" tIns="0" rIns="0" bIns="0" rtlCol="0" anchor="ctr"/>
           <a:lstStyle/>
           <a:p>
-            <a:pPr algn="ctr" indent="0" marL="0">
+            <a:pPr marL="0" indent="0" algn="ctr">
               <a:buNone/>
             </a:pPr>
             <a:r>
@@ -4432,7 +4201,7 @@
           <a:bodyPr wrap="square" lIns="0" tIns="0" rIns="0" bIns="0" rtlCol="0" anchor="ctr"/>
           <a:lstStyle/>
           <a:p>
-            <a:pPr indent="0" marL="0">
+            <a:pPr marL="0" indent="0">
               <a:buNone/>
             </a:pPr>
             <a:r>
@@ -4471,7 +4240,7 @@
           <a:bodyPr wrap="square" lIns="0" tIns="0" rIns="0" bIns="0" rtlCol="0" anchor="ctr"/>
           <a:lstStyle/>
           <a:p>
-            <a:pPr indent="0" marL="0">
+            <a:pPr marL="0" indent="0">
               <a:lnSpc>
                 <a:spcPct val="105000"/>
               </a:lnSpc>
@@ -4518,7 +4287,7 @@
             <a:prstDash val="solid"/>
           </a:ln>
           <a:effectLst>
-            <a:outerShdw sx="100000" sy="100000" kx="0" ky="0" algn="bl" rotWithShape="0" blurRad="88900" dist="25400" dir="8100000">
+            <a:outerShdw blurRad="88900" dist="25400" dir="8100000" algn="bl" rotWithShape="0">
               <a:srgbClr val="1B2A3A">
                 <a:alpha val="13000"/>
               </a:srgbClr>
@@ -4567,7 +4336,7 @@
           <a:bodyPr wrap="square" lIns="0" tIns="0" rIns="0" bIns="0" rtlCol="0" anchor="ctr"/>
           <a:lstStyle/>
           <a:p>
-            <a:pPr algn="ctr" indent="0" marL="0">
+            <a:pPr marL="0" indent="0" algn="ctr">
               <a:buNone/>
             </a:pPr>
             <a:r>
@@ -4606,7 +4375,7 @@
           <a:bodyPr wrap="square" lIns="0" tIns="0" rIns="0" bIns="0" rtlCol="0" anchor="ctr"/>
           <a:lstStyle/>
           <a:p>
-            <a:pPr indent="0" marL="0">
+            <a:pPr marL="0" indent="0">
               <a:buNone/>
             </a:pPr>
             <a:r>
@@ -4645,7 +4414,7 @@
           <a:bodyPr wrap="square" lIns="0" tIns="0" rIns="0" bIns="0" rtlCol="0" anchor="ctr"/>
           <a:lstStyle/>
           <a:p>
-            <a:pPr indent="0" marL="0">
+            <a:pPr marL="0" indent="0">
               <a:lnSpc>
                 <a:spcPct val="105000"/>
               </a:lnSpc>
@@ -4692,7 +4461,7 @@
             <a:prstDash val="solid"/>
           </a:ln>
           <a:effectLst>
-            <a:outerShdw sx="100000" sy="100000" kx="0" ky="0" algn="bl" rotWithShape="0" blurRad="88900" dist="25400" dir="8100000">
+            <a:outerShdw blurRad="88900" dist="25400" dir="8100000" algn="bl" rotWithShape="0">
               <a:srgbClr val="1B2A3A">
                 <a:alpha val="13000"/>
               </a:srgbClr>
@@ -4741,7 +4510,7 @@
           <a:bodyPr wrap="square" lIns="0" tIns="0" rIns="0" bIns="0" rtlCol="0" anchor="ctr"/>
           <a:lstStyle/>
           <a:p>
-            <a:pPr algn="ctr" indent="0" marL="0">
+            <a:pPr marL="0" indent="0" algn="ctr">
               <a:buNone/>
             </a:pPr>
             <a:r>
@@ -4780,7 +4549,7 @@
           <a:bodyPr wrap="square" lIns="0" tIns="0" rIns="0" bIns="0" rtlCol="0" anchor="ctr"/>
           <a:lstStyle/>
           <a:p>
-            <a:pPr indent="0" marL="0">
+            <a:pPr marL="0" indent="0">
               <a:buNone/>
             </a:pPr>
             <a:r>
@@ -4819,7 +4588,7 @@
           <a:bodyPr wrap="square" lIns="0" tIns="0" rIns="0" bIns="0" rtlCol="0" anchor="ctr"/>
           <a:lstStyle/>
           <a:p>
-            <a:pPr indent="0" marL="0">
+            <a:pPr marL="0" indent="0">
               <a:lnSpc>
                 <a:spcPct val="105000"/>
               </a:lnSpc>
@@ -4866,7 +4635,7 @@
             <a:prstDash val="solid"/>
           </a:ln>
           <a:effectLst>
-            <a:outerShdw sx="100000" sy="100000" kx="0" ky="0" algn="bl" rotWithShape="0" blurRad="88900" dist="25400" dir="8100000">
+            <a:outerShdw blurRad="88900" dist="25400" dir="8100000" algn="bl" rotWithShape="0">
               <a:srgbClr val="1B2A3A">
                 <a:alpha val="13000"/>
               </a:srgbClr>
@@ -4915,7 +4684,7 @@
           <a:bodyPr wrap="square" lIns="0" tIns="0" rIns="0" bIns="0" rtlCol="0" anchor="ctr"/>
           <a:lstStyle/>
           <a:p>
-            <a:pPr algn="ctr" indent="0" marL="0">
+            <a:pPr marL="0" indent="0" algn="ctr">
               <a:buNone/>
             </a:pPr>
             <a:r>
@@ -4954,7 +4723,7 @@
           <a:bodyPr wrap="square" lIns="0" tIns="0" rIns="0" bIns="0" rtlCol="0" anchor="ctr"/>
           <a:lstStyle/>
           <a:p>
-            <a:pPr indent="0" marL="0">
+            <a:pPr marL="0" indent="0">
               <a:buNone/>
             </a:pPr>
             <a:r>
@@ -4993,7 +4762,7 @@
           <a:bodyPr wrap="square" lIns="0" tIns="0" rIns="0" bIns="0" rtlCol="0" anchor="ctr"/>
           <a:lstStyle/>
           <a:p>
-            <a:pPr indent="0" marL="0">
+            <a:pPr marL="0" indent="0">
               <a:lnSpc>
                 <a:spcPct val="105000"/>
               </a:lnSpc>
@@ -5040,7 +4809,7 @@
             <a:prstDash val="solid"/>
           </a:ln>
           <a:effectLst>
-            <a:outerShdw sx="100000" sy="100000" kx="0" ky="0" algn="bl" rotWithShape="0" blurRad="88900" dist="25400" dir="8100000">
+            <a:outerShdw blurRad="88900" dist="25400" dir="8100000" algn="bl" rotWithShape="0">
               <a:srgbClr val="1B2A3A">
                 <a:alpha val="13000"/>
               </a:srgbClr>
@@ -5089,7 +4858,7 @@
           <a:bodyPr wrap="square" lIns="0" tIns="0" rIns="0" bIns="0" rtlCol="0" anchor="ctr"/>
           <a:lstStyle/>
           <a:p>
-            <a:pPr algn="ctr" indent="0" marL="0">
+            <a:pPr marL="0" indent="0" algn="ctr">
               <a:buNone/>
             </a:pPr>
             <a:r>
@@ -5128,7 +4897,7 @@
           <a:bodyPr wrap="square" lIns="0" tIns="0" rIns="0" bIns="0" rtlCol="0" anchor="ctr"/>
           <a:lstStyle/>
           <a:p>
-            <a:pPr indent="0" marL="0">
+            <a:pPr marL="0" indent="0">
               <a:buNone/>
             </a:pPr>
             <a:r>
@@ -5167,7 +4936,7 @@
           <a:bodyPr wrap="square" lIns="0" tIns="0" rIns="0" bIns="0" rtlCol="0" anchor="ctr"/>
           <a:lstStyle/>
           <a:p>
-            <a:pPr indent="0" marL="0">
+            <a:pPr marL="0" indent="0">
               <a:lnSpc>
                 <a:spcPct val="105000"/>
               </a:lnSpc>
@@ -5204,6 +4973,7 @@
         <a:solidFill>
           <a:srgbClr val="FFFFFF"/>
         </a:solidFill>
+        <a:effectLst/>
       </p:bgPr>
     </p:bg>
     <p:spTree>
@@ -5241,11 +5011,11 @@
           <a:bodyPr wrap="square" lIns="0" tIns="0" rIns="0" bIns="0" rtlCol="0" anchor="ctr"/>
           <a:lstStyle/>
           <a:p>
-            <a:pPr indent="0" marL="0">
-              <a:buNone/>
-            </a:pPr>
-            <a:r>
-              <a:rPr lang="en-US" sz="1100" b="1" spc="200" kern="0" dirty="0">
+            <a:pPr marL="0" indent="0">
+              <a:buNone/>
+            </a:pPr>
+            <a:r>
+              <a:rPr lang="en-US" sz="1100" b="1" kern="0" spc="200" dirty="0">
                 <a:solidFill>
                   <a:srgbClr val="2B6CB0"/>
                 </a:solidFill>
@@ -5280,7 +5050,7 @@
           <a:bodyPr wrap="square" lIns="0" tIns="0" rIns="0" bIns="0" rtlCol="0" anchor="ctr"/>
           <a:lstStyle/>
           <a:p>
-            <a:pPr indent="0" marL="0">
+            <a:pPr marL="0" indent="0">
               <a:buNone/>
             </a:pPr>
             <a:r>
@@ -5324,7 +5094,7 @@
             <a:prstDash val="solid"/>
           </a:ln>
           <a:effectLst>
-            <a:outerShdw sx="100000" sy="100000" kx="0" ky="0" algn="bl" rotWithShape="0" blurRad="88900" dist="25400" dir="8100000">
+            <a:outerShdw blurRad="88900" dist="25400" dir="8100000" algn="bl" rotWithShape="0">
               <a:srgbClr val="1B2A3A">
                 <a:alpha val="13000"/>
               </a:srgbClr>
@@ -5353,7 +5123,7 @@
           <a:bodyPr wrap="square" lIns="0" tIns="0" rIns="0" bIns="0" rtlCol="0" anchor="ctr"/>
           <a:lstStyle/>
           <a:p>
-            <a:pPr indent="0" marL="0">
+            <a:pPr marL="0" indent="0">
               <a:buNone/>
             </a:pPr>
             <a:r>
@@ -5392,7 +5162,7 @@
           <a:bodyPr wrap="square" lIns="0" tIns="0" rIns="0" bIns="0" rtlCol="0" anchor="ctr"/>
           <a:lstStyle/>
           <a:p>
-            <a:pPr indent="0" marL="0">
+            <a:pPr marL="0" indent="0">
               <a:buNone/>
             </a:pPr>
             <a:r>
@@ -5431,7 +5201,7 @@
           <a:bodyPr wrap="square" lIns="0" tIns="0" rIns="0" bIns="0" rtlCol="0" anchor="ctr"/>
           <a:lstStyle/>
           <a:p>
-            <a:pPr indent="0" marL="0">
+            <a:pPr marL="0" indent="0">
               <a:buNone/>
             </a:pPr>
             <a:r>
@@ -5475,7 +5245,7 @@
             <a:prstDash val="solid"/>
           </a:ln>
           <a:effectLst>
-            <a:outerShdw sx="100000" sy="100000" kx="0" ky="0" algn="bl" rotWithShape="0" blurRad="88900" dist="25400" dir="8100000">
+            <a:outerShdw blurRad="88900" dist="25400" dir="8100000" algn="bl" rotWithShape="0">
               <a:srgbClr val="1B2A3A">
                 <a:alpha val="13000"/>
               </a:srgbClr>
@@ -5504,7 +5274,7 @@
           <a:bodyPr wrap="square" lIns="0" tIns="0" rIns="0" bIns="0" rtlCol="0" anchor="ctr"/>
           <a:lstStyle/>
           <a:p>
-            <a:pPr indent="0" marL="0">
+            <a:pPr marL="0" indent="0">
               <a:buNone/>
             </a:pPr>
             <a:r>
@@ -5543,7 +5313,7 @@
           <a:bodyPr wrap="square" lIns="0" tIns="0" rIns="0" bIns="0" rtlCol="0" anchor="ctr"/>
           <a:lstStyle/>
           <a:p>
-            <a:pPr indent="0" marL="0">
+            <a:pPr marL="0" indent="0">
               <a:buNone/>
             </a:pPr>
             <a:r>
@@ -5582,7 +5352,7 @@
           <a:bodyPr wrap="square" lIns="0" tIns="0" rIns="0" bIns="0" rtlCol="0" anchor="ctr"/>
           <a:lstStyle/>
           <a:p>
-            <a:pPr indent="0" marL="0">
+            <a:pPr marL="0" indent="0">
               <a:buNone/>
             </a:pPr>
             <a:r>
@@ -5626,7 +5396,7 @@
             <a:prstDash val="solid"/>
           </a:ln>
           <a:effectLst>
-            <a:outerShdw sx="100000" sy="100000" kx="0" ky="0" algn="bl" rotWithShape="0" blurRad="88900" dist="25400" dir="8100000">
+            <a:outerShdw blurRad="88900" dist="25400" dir="8100000" algn="bl" rotWithShape="0">
               <a:srgbClr val="1B2A3A">
                 <a:alpha val="13000"/>
               </a:srgbClr>
@@ -5655,7 +5425,7 @@
           <a:bodyPr wrap="square" lIns="0" tIns="0" rIns="0" bIns="0" rtlCol="0" anchor="ctr"/>
           <a:lstStyle/>
           <a:p>
-            <a:pPr indent="0" marL="0">
+            <a:pPr marL="0" indent="0">
               <a:buNone/>
             </a:pPr>
             <a:r>
@@ -5694,7 +5464,7 @@
           <a:bodyPr wrap="square" lIns="0" tIns="0" rIns="0" bIns="0" rtlCol="0" anchor="ctr"/>
           <a:lstStyle/>
           <a:p>
-            <a:pPr indent="0" marL="0">
+            <a:pPr marL="0" indent="0">
               <a:buNone/>
             </a:pPr>
             <a:r>
@@ -5733,7 +5503,7 @@
           <a:bodyPr wrap="square" lIns="0" tIns="0" rIns="0" bIns="0" rtlCol="0" anchor="ctr"/>
           <a:lstStyle/>
           <a:p>
-            <a:pPr indent="0" marL="0">
+            <a:pPr marL="0" indent="0">
               <a:buNone/>
             </a:pPr>
             <a:r>
@@ -5777,7 +5547,7 @@
             <a:prstDash val="solid"/>
           </a:ln>
           <a:effectLst>
-            <a:outerShdw sx="100000" sy="100000" kx="0" ky="0" algn="bl" rotWithShape="0" blurRad="88900" dist="25400" dir="8100000">
+            <a:outerShdw blurRad="88900" dist="25400" dir="8100000" algn="bl" rotWithShape="0">
               <a:srgbClr val="1B2A3A">
                 <a:alpha val="13000"/>
               </a:srgbClr>
@@ -5806,7 +5576,7 @@
           <a:bodyPr wrap="square" lIns="0" tIns="0" rIns="0" bIns="0" rtlCol="0" anchor="ctr"/>
           <a:lstStyle/>
           <a:p>
-            <a:pPr indent="0" marL="0">
+            <a:pPr marL="0" indent="0">
               <a:buNone/>
             </a:pPr>
             <a:r>
@@ -5845,7 +5615,7 @@
           <a:bodyPr wrap="square" lIns="0" tIns="0" rIns="0" bIns="0" rtlCol="0" anchor="ctr"/>
           <a:lstStyle/>
           <a:p>
-            <a:pPr indent="0" marL="0">
+            <a:pPr marL="0" indent="0">
               <a:buNone/>
             </a:pPr>
             <a:r>
@@ -5884,7 +5654,7 @@
           <a:bodyPr wrap="square" lIns="0" tIns="0" rIns="0" bIns="0" rtlCol="0" anchor="ctr"/>
           <a:lstStyle/>
           <a:p>
-            <a:pPr indent="0" marL="0">
+            <a:pPr marL="0" indent="0">
               <a:buNone/>
             </a:pPr>
             <a:r>
@@ -5928,7 +5698,7 @@
             <a:prstDash val="solid"/>
           </a:ln>
           <a:effectLst>
-            <a:outerShdw sx="100000" sy="100000" kx="0" ky="0" algn="bl" rotWithShape="0" blurRad="88900" dist="25400" dir="8100000">
+            <a:outerShdw blurRad="88900" dist="25400" dir="8100000" algn="bl" rotWithShape="0">
               <a:srgbClr val="1B2A3A">
                 <a:alpha val="13000"/>
               </a:srgbClr>
@@ -5957,7 +5727,7 @@
           <a:bodyPr wrap="square" lIns="0" tIns="0" rIns="0" bIns="0" rtlCol="0" anchor="ctr"/>
           <a:lstStyle/>
           <a:p>
-            <a:pPr indent="0" marL="0">
+            <a:pPr marL="0" indent="0">
               <a:buNone/>
             </a:pPr>
             <a:r>
@@ -5996,7 +5766,7 @@
           <a:bodyPr wrap="square" lIns="0" tIns="0" rIns="0" bIns="0" rtlCol="0" anchor="ctr"/>
           <a:lstStyle/>
           <a:p>
-            <a:pPr indent="0" marL="0">
+            <a:pPr marL="0" indent="0">
               <a:buNone/>
             </a:pPr>
             <a:r>
@@ -6035,7 +5805,7 @@
           <a:bodyPr wrap="square" lIns="0" tIns="0" rIns="0" bIns="0" rtlCol="0" anchor="ctr"/>
           <a:lstStyle/>
           <a:p>
-            <a:pPr indent="0" marL="0">
+            <a:pPr marL="0" indent="0">
               <a:buNone/>
             </a:pPr>
             <a:r>
@@ -6069,6 +5839,7 @@
         <a:solidFill>
           <a:srgbClr val="FFFFFF"/>
         </a:solidFill>
+        <a:effectLst/>
       </p:bgPr>
     </p:bg>
     <p:spTree>
@@ -6106,11 +5877,11 @@
           <a:bodyPr wrap="square" lIns="0" tIns="0" rIns="0" bIns="0" rtlCol="0" anchor="ctr"/>
           <a:lstStyle/>
           <a:p>
-            <a:pPr indent="0" marL="0">
-              <a:buNone/>
-            </a:pPr>
-            <a:r>
-              <a:rPr lang="en-US" sz="1100" b="1" spc="200" kern="0" dirty="0">
+            <a:pPr marL="0" indent="0">
+              <a:buNone/>
+            </a:pPr>
+            <a:r>
+              <a:rPr lang="en-US" sz="1100" b="1" kern="0" spc="200" dirty="0">
                 <a:solidFill>
                   <a:srgbClr val="2B6CB0"/>
                 </a:solidFill>
@@ -6145,7 +5916,7 @@
           <a:bodyPr wrap="square" lIns="0" tIns="0" rIns="0" bIns="0" rtlCol="0" anchor="ctr"/>
           <a:lstStyle/>
           <a:p>
-            <a:pPr indent="0" marL="0">
+            <a:pPr marL="0" indent="0">
               <a:buNone/>
             </a:pPr>
             <a:r>
@@ -6189,7 +5960,7 @@
             <a:prstDash val="solid"/>
           </a:ln>
           <a:effectLst>
-            <a:outerShdw sx="100000" sy="100000" kx="0" ky="0" algn="bl" rotWithShape="0" blurRad="88900" dist="25400" dir="8100000">
+            <a:outerShdw blurRad="88900" dist="25400" dir="8100000" algn="bl" rotWithShape="0">
               <a:srgbClr val="1B2A3A">
                 <a:alpha val="13000"/>
               </a:srgbClr>
@@ -6218,7 +5989,7 @@
           <a:bodyPr wrap="square" lIns="0" tIns="0" rIns="0" bIns="0" rtlCol="0" anchor="ctr"/>
           <a:lstStyle/>
           <a:p>
-            <a:pPr indent="0" marL="0">
+            <a:pPr marL="0" indent="0">
               <a:buNone/>
             </a:pPr>
             <a:r>
@@ -6279,7 +6050,7 @@
           <a:bodyPr wrap="square" lIns="0" tIns="0" rIns="0" bIns="0" rtlCol="0" anchor="ctr"/>
           <a:lstStyle/>
           <a:p>
-            <a:pPr algn="ctr" indent="0" marL="0">
+            <a:pPr marL="0" indent="0" algn="ctr">
               <a:buNone/>
             </a:pPr>
             <a:r>
@@ -6318,7 +6089,7 @@
           <a:bodyPr wrap="square" lIns="0" tIns="0" rIns="0" bIns="0" rtlCol="0" anchor="ctr"/>
           <a:lstStyle/>
           <a:p>
-            <a:pPr indent="0" marL="0">
+            <a:pPr marL="0" indent="0">
               <a:lnSpc>
                 <a:spcPct val="105000"/>
               </a:lnSpc>
@@ -6365,7 +6136,7 @@
             <a:prstDash val="solid"/>
           </a:ln>
           <a:effectLst>
-            <a:outerShdw sx="100000" sy="100000" kx="0" ky="0" algn="bl" rotWithShape="0" blurRad="88900" dist="25400" dir="8100000">
+            <a:outerShdw blurRad="88900" dist="25400" dir="8100000" algn="bl" rotWithShape="0">
               <a:srgbClr val="1B2A3A">
                 <a:alpha val="13000"/>
               </a:srgbClr>
@@ -6394,7 +6165,7 @@
           <a:bodyPr wrap="square" lIns="0" tIns="0" rIns="0" bIns="0" rtlCol="0" anchor="ctr"/>
           <a:lstStyle/>
           <a:p>
-            <a:pPr indent="0" marL="0">
+            <a:pPr marL="0" indent="0">
               <a:buNone/>
             </a:pPr>
             <a:r>
@@ -6455,7 +6226,7 @@
           <a:bodyPr wrap="square" lIns="0" tIns="0" rIns="0" bIns="0" rtlCol="0" anchor="ctr"/>
           <a:lstStyle/>
           <a:p>
-            <a:pPr algn="ctr" indent="0" marL="0">
+            <a:pPr marL="0" indent="0" algn="ctr">
               <a:buNone/>
             </a:pPr>
             <a:r>
@@ -6494,7 +6265,7 @@
           <a:bodyPr wrap="square" lIns="0" tIns="0" rIns="0" bIns="0" rtlCol="0" anchor="ctr"/>
           <a:lstStyle/>
           <a:p>
-            <a:pPr indent="0" marL="0">
+            <a:pPr marL="0" indent="0">
               <a:lnSpc>
                 <a:spcPct val="105000"/>
               </a:lnSpc>
@@ -6541,7 +6312,7 @@
             <a:prstDash val="solid"/>
           </a:ln>
           <a:effectLst>
-            <a:outerShdw sx="100000" sy="100000" kx="0" ky="0" algn="bl" rotWithShape="0" blurRad="88900" dist="25400" dir="8100000">
+            <a:outerShdw blurRad="88900" dist="25400" dir="8100000" algn="bl" rotWithShape="0">
               <a:srgbClr val="1B2A3A">
                 <a:alpha val="13000"/>
               </a:srgbClr>
@@ -6570,7 +6341,7 @@
           <a:bodyPr wrap="square" lIns="0" tIns="0" rIns="0" bIns="0" rtlCol="0" anchor="ctr"/>
           <a:lstStyle/>
           <a:p>
-            <a:pPr indent="0" marL="0">
+            <a:pPr marL="0" indent="0">
               <a:buNone/>
             </a:pPr>
             <a:r>
@@ -6631,7 +6402,7 @@
           <a:bodyPr wrap="square" lIns="0" tIns="0" rIns="0" bIns="0" rtlCol="0" anchor="ctr"/>
           <a:lstStyle/>
           <a:p>
-            <a:pPr algn="ctr" indent="0" marL="0">
+            <a:pPr marL="0" indent="0" algn="ctr">
               <a:buNone/>
             </a:pPr>
             <a:r>
@@ -6670,7 +6441,7 @@
           <a:bodyPr wrap="square" lIns="0" tIns="0" rIns="0" bIns="0" rtlCol="0" anchor="ctr"/>
           <a:lstStyle/>
           <a:p>
-            <a:pPr indent="0" marL="0">
+            <a:pPr marL="0" indent="0">
               <a:lnSpc>
                 <a:spcPct val="105000"/>
               </a:lnSpc>
@@ -6717,7 +6488,7 @@
             <a:prstDash val="solid"/>
           </a:ln>
           <a:effectLst>
-            <a:outerShdw sx="100000" sy="100000" kx="0" ky="0" algn="bl" rotWithShape="0" blurRad="88900" dist="25400" dir="8100000">
+            <a:outerShdw blurRad="88900" dist="25400" dir="8100000" algn="bl" rotWithShape="0">
               <a:srgbClr val="1B2A3A">
                 <a:alpha val="13000"/>
               </a:srgbClr>
@@ -6746,7 +6517,7 @@
           <a:bodyPr wrap="square" lIns="0" tIns="0" rIns="0" bIns="0" rtlCol="0" anchor="ctr"/>
           <a:lstStyle/>
           <a:p>
-            <a:pPr indent="0" marL="0">
+            <a:pPr marL="0" indent="0">
               <a:buNone/>
             </a:pPr>
             <a:r>
@@ -6807,7 +6578,7 @@
           <a:bodyPr wrap="square" lIns="0" tIns="0" rIns="0" bIns="0" rtlCol="0" anchor="ctr"/>
           <a:lstStyle/>
           <a:p>
-            <a:pPr algn="ctr" indent="0" marL="0">
+            <a:pPr marL="0" indent="0" algn="ctr">
               <a:buNone/>
             </a:pPr>
             <a:r>
@@ -6846,7 +6617,7 @@
           <a:bodyPr wrap="square" lIns="0" tIns="0" rIns="0" bIns="0" rtlCol="0" anchor="ctr"/>
           <a:lstStyle/>
           <a:p>
-            <a:pPr indent="0" marL="0">
+            <a:pPr marL="0" indent="0">
               <a:lnSpc>
                 <a:spcPct val="105000"/>
               </a:lnSpc>
@@ -6883,6 +6654,7 @@
         <a:solidFill>
           <a:srgbClr val="1B2A3A"/>
         </a:solidFill>
+        <a:effectLst/>
       </p:bgPr>
     </p:bg>
     <p:spTree>
@@ -6940,11 +6712,11 @@
           <a:bodyPr wrap="square" lIns="0" tIns="0" rIns="0" bIns="0" rtlCol="0" anchor="ctr"/>
           <a:lstStyle/>
           <a:p>
-            <a:pPr indent="0" marL="0">
-              <a:buNone/>
-            </a:pPr>
-            <a:r>
-              <a:rPr lang="en-US" sz="1200" b="1" spc="200" kern="0" dirty="0">
+            <a:pPr marL="0" indent="0">
+              <a:buNone/>
+            </a:pPr>
+            <a:r>
+              <a:rPr lang="en-US" sz="1200" b="1" kern="0" spc="200" dirty="0">
                 <a:solidFill>
                   <a:srgbClr val="8FB4DC"/>
                 </a:solidFill>
@@ -6979,7 +6751,7 @@
           <a:bodyPr wrap="square" lIns="0" tIns="0" rIns="0" bIns="0" rtlCol="0" anchor="ctr"/>
           <a:lstStyle/>
           <a:p>
-            <a:pPr indent="0" marL="0">
+            <a:pPr marL="0" indent="0">
               <a:buNone/>
             </a:pPr>
             <a:r>
@@ -7038,7 +6810,7 @@
           <a:bodyPr wrap="square" lIns="0" tIns="0" rIns="0" bIns="0" rtlCol="0" anchor="ctr"/>
           <a:lstStyle/>
           <a:p>
-            <a:pPr indent="0" marL="0">
+            <a:pPr marL="0" indent="0">
               <a:buNone/>
             </a:pPr>
             <a:r>
@@ -7097,7 +6869,7 @@
           <a:bodyPr wrap="square" lIns="0" tIns="0" rIns="0" bIns="0" rtlCol="0" anchor="ctr"/>
           <a:lstStyle/>
           <a:p>
-            <a:pPr indent="0" marL="0">
+            <a:pPr marL="0" indent="0">
               <a:buNone/>
             </a:pPr>
             <a:r>
@@ -7156,7 +6928,7 @@
           <a:bodyPr wrap="square" lIns="0" tIns="0" rIns="0" bIns="0" rtlCol="0" anchor="ctr"/>
           <a:lstStyle/>
           <a:p>
-            <a:pPr indent="0" marL="0">
+            <a:pPr marL="0" indent="0">
               <a:buNone/>
             </a:pPr>
             <a:r>
@@ -7215,7 +6987,7 @@
           <a:bodyPr wrap="square" lIns="0" tIns="0" rIns="0" bIns="0" rtlCol="0" anchor="ctr"/>
           <a:lstStyle/>
           <a:p>
-            <a:pPr indent="0" marL="0">
+            <a:pPr marL="0" indent="0">
               <a:buNone/>
             </a:pPr>
             <a:r>
@@ -7254,7 +7026,7 @@
           <a:bodyPr wrap="square" lIns="0" tIns="0" rIns="0" bIns="0" rtlCol="0" anchor="ctr"/>
           <a:lstStyle/>
           <a:p>
-            <a:pPr indent="0" marL="0">
+            <a:pPr marL="0" indent="0">
               <a:buNone/>
             </a:pPr>
             <a:r>
@@ -7288,6 +7060,7 @@
         <a:solidFill>
           <a:srgbClr val="FFFFFF"/>
         </a:solidFill>
+        <a:effectLst/>
       </p:bgPr>
     </p:bg>
     <p:spTree>
@@ -7312,7 +7085,7 @@
         </p:nvSpPr>
         <p:spPr>
           <a:xfrm>
-            <a:off x="457200" y="310896"/>
+            <a:off x="457200" y="243166"/>
             <a:ext cx="8229600" cy="228600"/>
           </a:xfrm>
           <a:prstGeom prst="rect">
@@ -7325,11 +7098,11 @@
           <a:bodyPr wrap="square" lIns="0" tIns="0" rIns="0" bIns="0" rtlCol="0" anchor="ctr"/>
           <a:lstStyle/>
           <a:p>
-            <a:pPr indent="0" marL="0">
-              <a:buNone/>
-            </a:pPr>
-            <a:r>
-              <a:rPr lang="en-US" sz="1100" b="1" spc="200" kern="0" dirty="0">
+            <a:pPr marL="0" indent="0">
+              <a:buNone/>
+            </a:pPr>
+            <a:r>
+              <a:rPr lang="en-US" sz="1100" b="1" kern="0" spc="200" dirty="0">
                 <a:solidFill>
                   <a:srgbClr val="2B6CB0"/>
                 </a:solidFill>
@@ -7351,7 +7124,7 @@
         </p:nvSpPr>
         <p:spPr>
           <a:xfrm>
-            <a:off x="457200" y="512064"/>
+            <a:off x="457200" y="579794"/>
             <a:ext cx="8229600" cy="548640"/>
           </a:xfrm>
           <a:prstGeom prst="rect">
@@ -7364,7 +7137,7 @@
           <a:bodyPr wrap="square" lIns="0" tIns="0" rIns="0" bIns="0" rtlCol="0" anchor="ctr"/>
           <a:lstStyle/>
           <a:p>
-            <a:pPr indent="0" marL="0">
+            <a:pPr marL="0" indent="0">
               <a:buNone/>
             </a:pPr>
             <a:r>
@@ -7403,7 +7176,7 @@
           <a:bodyPr wrap="square" lIns="0" tIns="0" rIns="0" bIns="0" rtlCol="0" anchor="ctr"/>
           <a:lstStyle/>
           <a:p>
-            <a:pPr indent="0" marL="0">
+            <a:pPr marL="0" indent="0">
               <a:lnSpc>
                 <a:spcPct val="112000"/>
               </a:lnSpc>
@@ -7450,7 +7223,7 @@
             <a:prstDash val="solid"/>
           </a:ln>
           <a:effectLst>
-            <a:outerShdw sx="100000" sy="100000" kx="0" ky="0" algn="bl" rotWithShape="0" blurRad="88900" dist="25400" dir="8100000">
+            <a:outerShdw blurRad="88900" dist="25400" dir="8100000" algn="bl" rotWithShape="0">
               <a:srgbClr val="1B2A3A">
                 <a:alpha val="13000"/>
               </a:srgbClr>
@@ -7479,7 +7252,7 @@
           <a:bodyPr wrap="square" lIns="0" tIns="0" rIns="0" bIns="0" rtlCol="0" anchor="ctr"/>
           <a:lstStyle/>
           <a:p>
-            <a:pPr algn="ctr" indent="0" marL="0">
+            <a:pPr marL="0" indent="0" algn="ctr">
               <a:buNone/>
             </a:pPr>
             <a:r>
@@ -7518,7 +7291,7 @@
           <a:bodyPr wrap="square" lIns="0" tIns="0" rIns="0" bIns="0" rtlCol="0" anchor="ctr"/>
           <a:lstStyle/>
           <a:p>
-            <a:pPr algn="ctr" indent="0" marL="0">
+            <a:pPr marL="0" indent="0" algn="ctr">
               <a:buNone/>
             </a:pPr>
             <a:r>
@@ -7562,7 +7335,7 @@
             <a:prstDash val="solid"/>
           </a:ln>
           <a:effectLst>
-            <a:outerShdw sx="100000" sy="100000" kx="0" ky="0" algn="bl" rotWithShape="0" blurRad="88900" dist="25400" dir="8100000">
+            <a:outerShdw blurRad="88900" dist="25400" dir="8100000" algn="bl" rotWithShape="0">
               <a:srgbClr val="1B2A3A">
                 <a:alpha val="13000"/>
               </a:srgbClr>
@@ -7611,7 +7384,7 @@
           <a:bodyPr wrap="square" lIns="0" tIns="0" rIns="0" bIns="0" rtlCol="0" anchor="ctr"/>
           <a:lstStyle/>
           <a:p>
-            <a:pPr algn="ctr" indent="0" marL="0">
+            <a:pPr marL="0" indent="0" algn="ctr">
               <a:buNone/>
             </a:pPr>
             <a:r>
@@ -7650,7 +7423,7 @@
           <a:bodyPr wrap="square" lIns="0" tIns="0" rIns="0" bIns="0" rtlCol="0" anchor="ctr"/>
           <a:lstStyle/>
           <a:p>
-            <a:pPr indent="0" marL="0">
+            <a:pPr marL="0" indent="0">
               <a:buNone/>
             </a:pPr>
             <a:r>
@@ -7668,7 +7441,7 @@
             <a:endParaRPr lang="en-US" sz="1350" dirty="0"/>
           </a:p>
           <a:p>
-            <a:pPr indent="0" marL="0">
+            <a:pPr marL="0" indent="0">
               <a:buNone/>
             </a:pPr>
             <a:r>
@@ -7712,7 +7485,7 @@
             <a:prstDash val="solid"/>
           </a:ln>
           <a:effectLst>
-            <a:outerShdw sx="100000" sy="100000" kx="0" ky="0" algn="bl" rotWithShape="0" blurRad="88900" dist="25400" dir="8100000">
+            <a:outerShdw blurRad="88900" dist="25400" dir="8100000" algn="bl" rotWithShape="0">
               <a:srgbClr val="1B2A3A">
                 <a:alpha val="13000"/>
               </a:srgbClr>
@@ -7761,7 +7534,7 @@
           <a:bodyPr wrap="square" lIns="0" tIns="0" rIns="0" bIns="0" rtlCol="0" anchor="ctr"/>
           <a:lstStyle/>
           <a:p>
-            <a:pPr algn="ctr" indent="0" marL="0">
+            <a:pPr marL="0" indent="0" algn="ctr">
               <a:buNone/>
             </a:pPr>
             <a:r>
@@ -7800,7 +7573,7 @@
           <a:bodyPr wrap="square" lIns="0" tIns="0" rIns="0" bIns="0" rtlCol="0" anchor="ctr"/>
           <a:lstStyle/>
           <a:p>
-            <a:pPr indent="0" marL="0">
+            <a:pPr marL="0" indent="0">
               <a:buNone/>
             </a:pPr>
             <a:r>
@@ -7818,7 +7591,7 @@
             <a:endParaRPr lang="en-US" sz="1350" dirty="0"/>
           </a:p>
           <a:p>
-            <a:pPr indent="0" marL="0">
+            <a:pPr marL="0" indent="0">
               <a:buNone/>
             </a:pPr>
             <a:r>
@@ -7862,7 +7635,7 @@
             <a:prstDash val="solid"/>
           </a:ln>
           <a:effectLst>
-            <a:outerShdw sx="100000" sy="100000" kx="0" ky="0" algn="bl" rotWithShape="0" blurRad="88900" dist="25400" dir="8100000">
+            <a:outerShdw blurRad="88900" dist="25400" dir="8100000" algn="bl" rotWithShape="0">
               <a:srgbClr val="1B2A3A">
                 <a:alpha val="13000"/>
               </a:srgbClr>
@@ -7911,7 +7684,7 @@
           <a:bodyPr wrap="square" lIns="0" tIns="0" rIns="0" bIns="0" rtlCol="0" anchor="ctr"/>
           <a:lstStyle/>
           <a:p>
-            <a:pPr algn="ctr" indent="0" marL="0">
+            <a:pPr marL="0" indent="0" algn="ctr">
               <a:buNone/>
             </a:pPr>
             <a:r>
@@ -7950,7 +7723,7 @@
           <a:bodyPr wrap="square" lIns="0" tIns="0" rIns="0" bIns="0" rtlCol="0" anchor="ctr"/>
           <a:lstStyle/>
           <a:p>
-            <a:pPr indent="0" marL="0">
+            <a:pPr marL="0" indent="0">
               <a:buNone/>
             </a:pPr>
             <a:r>
@@ -7968,7 +7741,7 @@
             <a:endParaRPr lang="en-US" sz="1350" dirty="0"/>
           </a:p>
           <a:p>
-            <a:pPr indent="0" marL="0">
+            <a:pPr marL="0" indent="0">
               <a:buNone/>
             </a:pPr>
             <a:r>
@@ -8012,7 +7785,7 @@
             <a:prstDash val="solid"/>
           </a:ln>
           <a:effectLst>
-            <a:outerShdw sx="100000" sy="100000" kx="0" ky="0" algn="bl" rotWithShape="0" blurRad="88900" dist="25400" dir="8100000">
+            <a:outerShdw blurRad="88900" dist="25400" dir="8100000" algn="bl" rotWithShape="0">
               <a:srgbClr val="1B2A3A">
                 <a:alpha val="13000"/>
               </a:srgbClr>
@@ -8061,7 +7834,7 @@
           <a:bodyPr wrap="square" lIns="0" tIns="0" rIns="0" bIns="0" rtlCol="0" anchor="ctr"/>
           <a:lstStyle/>
           <a:p>
-            <a:pPr algn="ctr" indent="0" marL="0">
+            <a:pPr marL="0" indent="0" algn="ctr">
               <a:buNone/>
             </a:pPr>
             <a:r>
@@ -8100,7 +7873,7 @@
           <a:bodyPr wrap="square" lIns="0" tIns="0" rIns="0" bIns="0" rtlCol="0" anchor="ctr"/>
           <a:lstStyle/>
           <a:p>
-            <a:pPr indent="0" marL="0">
+            <a:pPr marL="0" indent="0">
               <a:buNone/>
             </a:pPr>
             <a:r>
@@ -8118,7 +7891,7 @@
             <a:endParaRPr lang="en-US" sz="1350" dirty="0"/>
           </a:p>
           <a:p>
-            <a:pPr indent="0" marL="0">
+            <a:pPr marL="0" indent="0">
               <a:buNone/>
             </a:pPr>
             <a:r>
@@ -8162,7 +7935,7 @@
             <a:prstDash val="solid"/>
           </a:ln>
           <a:effectLst>
-            <a:outerShdw sx="100000" sy="100000" kx="0" ky="0" algn="bl" rotWithShape="0" blurRad="88900" dist="25400" dir="8100000">
+            <a:outerShdw blurRad="88900" dist="25400" dir="8100000" algn="bl" rotWithShape="0">
               <a:srgbClr val="1B2A3A">
                 <a:alpha val="13000"/>
               </a:srgbClr>
@@ -8211,7 +7984,7 @@
           <a:bodyPr wrap="square" lIns="0" tIns="0" rIns="0" bIns="0" rtlCol="0" anchor="ctr"/>
           <a:lstStyle/>
           <a:p>
-            <a:pPr algn="ctr" indent="0" marL="0">
+            <a:pPr marL="0" indent="0" algn="ctr">
               <a:buNone/>
             </a:pPr>
             <a:r>
@@ -8250,7 +8023,7 @@
           <a:bodyPr wrap="square" lIns="0" tIns="0" rIns="0" bIns="0" rtlCol="0" anchor="ctr"/>
           <a:lstStyle/>
           <a:p>
-            <a:pPr indent="0" marL="0">
+            <a:pPr marL="0" indent="0">
               <a:buNone/>
             </a:pPr>
             <a:r>
@@ -8268,7 +8041,7 @@
             <a:endParaRPr lang="en-US" sz="1350" dirty="0"/>
           </a:p>
           <a:p>
-            <a:pPr indent="0" marL="0">
+            <a:pPr marL="0" indent="0">
               <a:buNone/>
             </a:pPr>
             <a:r>
@@ -8302,6 +8075,7 @@
         <a:solidFill>
           <a:srgbClr val="FFFFFF"/>
         </a:solidFill>
+        <a:effectLst/>
       </p:bgPr>
     </p:bg>
     <p:spTree>
@@ -8339,11 +8113,11 @@
           <a:bodyPr wrap="square" lIns="0" tIns="0" rIns="0" bIns="0" rtlCol="0" anchor="ctr"/>
           <a:lstStyle/>
           <a:p>
-            <a:pPr indent="0" marL="0">
-              <a:buNone/>
-            </a:pPr>
-            <a:r>
-              <a:rPr lang="en-US" sz="1100" b="1" spc="200" kern="0" dirty="0">
+            <a:pPr marL="0" indent="0">
+              <a:buNone/>
+            </a:pPr>
+            <a:r>
+              <a:rPr lang="en-US" sz="1100" b="1" kern="0" spc="200" dirty="0">
                 <a:solidFill>
                   <a:srgbClr val="2B6CB0"/>
                 </a:solidFill>
@@ -8378,7 +8152,7 @@
           <a:bodyPr wrap="square" lIns="0" tIns="0" rIns="0" bIns="0" rtlCol="0" anchor="ctr"/>
           <a:lstStyle/>
           <a:p>
-            <a:pPr indent="0" marL="0">
+            <a:pPr marL="0" indent="0">
               <a:buNone/>
             </a:pPr>
             <a:r>
@@ -8422,7 +8196,7 @@
             <a:prstDash val="solid"/>
           </a:ln>
           <a:effectLst>
-            <a:outerShdw sx="100000" sy="100000" kx="0" ky="0" algn="bl" rotWithShape="0" blurRad="88900" dist="25400" dir="8100000">
+            <a:outerShdw blurRad="88900" dist="25400" dir="8100000" algn="bl" rotWithShape="0">
               <a:srgbClr val="1B2A3A">
                 <a:alpha val="13000"/>
               </a:srgbClr>
@@ -8451,11 +8225,11 @@
           <a:bodyPr wrap="square" lIns="0" tIns="0" rIns="0" bIns="0" rtlCol="0" anchor="ctr"/>
           <a:lstStyle/>
           <a:p>
-            <a:pPr indent="0" marL="0">
-              <a:buNone/>
-            </a:pPr>
-            <a:r>
-              <a:rPr lang="en-US" sz="1200" b="1" spc="100" kern="0" dirty="0">
+            <a:pPr marL="0" indent="0">
+              <a:buNone/>
+            </a:pPr>
+            <a:r>
+              <a:rPr lang="en-US" sz="1200" b="1" kern="0" spc="100" dirty="0">
                 <a:solidFill>
                   <a:srgbClr val="5B7085"/>
                 </a:solidFill>
@@ -8490,7 +8264,7 @@
           <a:bodyPr wrap="square" lIns="0" tIns="0" rIns="0" bIns="0" rtlCol="0" anchor="ctr"/>
           <a:lstStyle/>
           <a:p>
-            <a:pPr indent="0" marL="0">
+            <a:pPr marL="0" indent="0">
               <a:buNone/>
             </a:pPr>
             <a:r>
@@ -8660,7 +8434,7 @@
             <a:prstDash val="solid"/>
           </a:ln>
           <a:effectLst>
-            <a:outerShdw sx="100000" sy="100000" kx="0" ky="0" algn="bl" rotWithShape="0" blurRad="88900" dist="25400" dir="8100000">
+            <a:outerShdw blurRad="88900" dist="25400" dir="8100000" algn="bl" rotWithShape="0">
               <a:srgbClr val="1B2A3A">
                 <a:alpha val="13000"/>
               </a:srgbClr>
@@ -8689,11 +8463,11 @@
           <a:bodyPr wrap="square" lIns="0" tIns="0" rIns="0" bIns="0" rtlCol="0" anchor="ctr"/>
           <a:lstStyle/>
           <a:p>
-            <a:pPr indent="0" marL="0">
-              <a:buNone/>
-            </a:pPr>
-            <a:r>
-              <a:rPr lang="en-US" sz="1200" b="1" spc="100" kern="0" dirty="0">
+            <a:pPr marL="0" indent="0">
+              <a:buNone/>
+            </a:pPr>
+            <a:r>
+              <a:rPr lang="en-US" sz="1200" b="1" kern="0" spc="100" dirty="0">
                 <a:solidFill>
                   <a:srgbClr val="8FB4DC"/>
                 </a:solidFill>
@@ -8728,7 +8502,7 @@
           <a:bodyPr wrap="square" lIns="0" tIns="0" rIns="0" bIns="0" rtlCol="0" anchor="ctr"/>
           <a:lstStyle/>
           <a:p>
-            <a:pPr indent="0" marL="0">
+            <a:pPr marL="0" indent="0">
               <a:buNone/>
             </a:pPr>
             <a:r>
@@ -8868,6 +8642,7 @@
         <a:solidFill>
           <a:srgbClr val="FFFFFF"/>
         </a:solidFill>
+        <a:effectLst/>
       </p:bgPr>
     </p:bg>
     <p:spTree>
@@ -8905,11 +8680,11 @@
           <a:bodyPr wrap="square" lIns="0" tIns="0" rIns="0" bIns="0" rtlCol="0" anchor="ctr"/>
           <a:lstStyle/>
           <a:p>
-            <a:pPr indent="0" marL="0">
-              <a:buNone/>
-            </a:pPr>
-            <a:r>
-              <a:rPr lang="en-US" sz="1100" b="1" spc="200" kern="0" dirty="0">
+            <a:pPr marL="0" indent="0">
+              <a:buNone/>
+            </a:pPr>
+            <a:r>
+              <a:rPr lang="en-US" sz="1100" b="1" kern="0" spc="200" dirty="0">
                 <a:solidFill>
                   <a:srgbClr val="2B6CB0"/>
                 </a:solidFill>
@@ -8944,7 +8719,7 @@
           <a:bodyPr wrap="square" lIns="0" tIns="0" rIns="0" bIns="0" rtlCol="0" anchor="ctr"/>
           <a:lstStyle/>
           <a:p>
-            <a:pPr indent="0" marL="0">
+            <a:pPr marL="0" indent="0">
               <a:buNone/>
             </a:pPr>
             <a:r>
@@ -8988,7 +8763,7 @@
             <a:prstDash val="solid"/>
           </a:ln>
           <a:effectLst>
-            <a:outerShdw sx="100000" sy="100000" kx="0" ky="0" algn="bl" rotWithShape="0" blurRad="88900" dist="25400" dir="8100000">
+            <a:outerShdw blurRad="88900" dist="25400" dir="8100000" algn="bl" rotWithShape="0">
               <a:srgbClr val="1B2A3A">
                 <a:alpha val="13000"/>
               </a:srgbClr>
@@ -9037,7 +8812,7 @@
           <a:bodyPr wrap="square" lIns="0" tIns="0" rIns="0" bIns="0" rtlCol="0" anchor="ctr"/>
           <a:lstStyle/>
           <a:p>
-            <a:pPr algn="ctr" indent="0" marL="0">
+            <a:pPr marL="0" indent="0" algn="ctr">
               <a:buNone/>
             </a:pPr>
             <a:r>
@@ -9076,7 +8851,7 @@
           <a:bodyPr wrap="square" lIns="0" tIns="0" rIns="0" bIns="0" rtlCol="0" anchor="ctr"/>
           <a:lstStyle/>
           <a:p>
-            <a:pPr algn="ctr" indent="0" marL="0">
+            <a:pPr marL="0" indent="0" algn="ctr">
               <a:buNone/>
             </a:pPr>
             <a:r>
@@ -9115,7 +8890,7 @@
           <a:bodyPr wrap="square" lIns="0" tIns="0" rIns="0" bIns="0" rtlCol="0" anchor="ctr"/>
           <a:lstStyle/>
           <a:p>
-            <a:pPr algn="ctr" indent="0" marL="0">
+            <a:pPr marL="0" indent="0" algn="ctr">
               <a:buNone/>
             </a:pPr>
             <a:r>
@@ -9154,7 +8929,7 @@
           <a:bodyPr wrap="square" lIns="0" tIns="0" rIns="0" bIns="0" rtlCol="0" anchor="ctr"/>
           <a:lstStyle/>
           <a:p>
-            <a:pPr algn="ctr" indent="0" marL="0">
+            <a:pPr marL="0" indent="0" algn="ctr">
               <a:buNone/>
             </a:pPr>
             <a:r>
@@ -9218,7 +8993,7 @@
             <a:prstDash val="solid"/>
           </a:ln>
           <a:effectLst>
-            <a:outerShdw sx="100000" sy="100000" kx="0" ky="0" algn="bl" rotWithShape="0" blurRad="88900" dist="25400" dir="8100000">
+            <a:outerShdw blurRad="88900" dist="25400" dir="8100000" algn="bl" rotWithShape="0">
               <a:srgbClr val="1B2A3A">
                 <a:alpha val="13000"/>
               </a:srgbClr>
@@ -9267,7 +9042,7 @@
           <a:bodyPr wrap="square" lIns="0" tIns="0" rIns="0" bIns="0" rtlCol="0" anchor="ctr"/>
           <a:lstStyle/>
           <a:p>
-            <a:pPr algn="ctr" indent="0" marL="0">
+            <a:pPr marL="0" indent="0" algn="ctr">
               <a:buNone/>
             </a:pPr>
             <a:r>
@@ -9306,7 +9081,7 @@
           <a:bodyPr wrap="square" lIns="0" tIns="0" rIns="0" bIns="0" rtlCol="0" anchor="ctr"/>
           <a:lstStyle/>
           <a:p>
-            <a:pPr algn="ctr" indent="0" marL="0">
+            <a:pPr marL="0" indent="0" algn="ctr">
               <a:buNone/>
             </a:pPr>
             <a:r>
@@ -9345,7 +9120,7 @@
           <a:bodyPr wrap="square" lIns="0" tIns="0" rIns="0" bIns="0" rtlCol="0" anchor="ctr"/>
           <a:lstStyle/>
           <a:p>
-            <a:pPr algn="ctr" indent="0" marL="0">
+            <a:pPr marL="0" indent="0" algn="ctr">
               <a:buNone/>
             </a:pPr>
             <a:r>
@@ -9384,7 +9159,7 @@
           <a:bodyPr wrap="square" lIns="0" tIns="0" rIns="0" bIns="0" rtlCol="0" anchor="ctr"/>
           <a:lstStyle/>
           <a:p>
-            <a:pPr algn="ctr" indent="0" marL="0">
+            <a:pPr marL="0" indent="0" algn="ctr">
               <a:buNone/>
             </a:pPr>
             <a:r>
@@ -9448,7 +9223,7 @@
             <a:prstDash val="solid"/>
           </a:ln>
           <a:effectLst>
-            <a:outerShdw sx="100000" sy="100000" kx="0" ky="0" algn="bl" rotWithShape="0" blurRad="88900" dist="25400" dir="8100000">
+            <a:outerShdw blurRad="88900" dist="25400" dir="8100000" algn="bl" rotWithShape="0">
               <a:srgbClr val="1B2A3A">
                 <a:alpha val="13000"/>
               </a:srgbClr>
@@ -9497,7 +9272,7 @@
           <a:bodyPr wrap="square" lIns="0" tIns="0" rIns="0" bIns="0" rtlCol="0" anchor="ctr"/>
           <a:lstStyle/>
           <a:p>
-            <a:pPr algn="ctr" indent="0" marL="0">
+            <a:pPr marL="0" indent="0" algn="ctr">
               <a:buNone/>
             </a:pPr>
             <a:r>
@@ -9536,7 +9311,7 @@
           <a:bodyPr wrap="square" lIns="0" tIns="0" rIns="0" bIns="0" rtlCol="0" anchor="ctr"/>
           <a:lstStyle/>
           <a:p>
-            <a:pPr algn="ctr" indent="0" marL="0">
+            <a:pPr marL="0" indent="0" algn="ctr">
               <a:buNone/>
             </a:pPr>
             <a:r>
@@ -9575,7 +9350,7 @@
           <a:bodyPr wrap="square" lIns="0" tIns="0" rIns="0" bIns="0" rtlCol="0" anchor="ctr"/>
           <a:lstStyle/>
           <a:p>
-            <a:pPr algn="ctr" indent="0" marL="0">
+            <a:pPr marL="0" indent="0" algn="ctr">
               <a:buNone/>
             </a:pPr>
             <a:r>
@@ -9614,7 +9389,7 @@
           <a:bodyPr wrap="square" lIns="0" tIns="0" rIns="0" bIns="0" rtlCol="0" anchor="ctr"/>
           <a:lstStyle/>
           <a:p>
-            <a:pPr algn="ctr" indent="0" marL="0">
+            <a:pPr marL="0" indent="0" algn="ctr">
               <a:buNone/>
             </a:pPr>
             <a:r>
@@ -9678,7 +9453,7 @@
             <a:prstDash val="solid"/>
           </a:ln>
           <a:effectLst>
-            <a:outerShdw sx="100000" sy="100000" kx="0" ky="0" algn="bl" rotWithShape="0" blurRad="88900" dist="25400" dir="8100000">
+            <a:outerShdw blurRad="88900" dist="25400" dir="8100000" algn="bl" rotWithShape="0">
               <a:srgbClr val="1B2A3A">
                 <a:alpha val="13000"/>
               </a:srgbClr>
@@ -9727,7 +9502,7 @@
           <a:bodyPr wrap="square" lIns="0" tIns="0" rIns="0" bIns="0" rtlCol="0" anchor="ctr"/>
           <a:lstStyle/>
           <a:p>
-            <a:pPr algn="ctr" indent="0" marL="0">
+            <a:pPr marL="0" indent="0" algn="ctr">
               <a:buNone/>
             </a:pPr>
             <a:r>
@@ -9766,7 +9541,7 @@
           <a:bodyPr wrap="square" lIns="0" tIns="0" rIns="0" bIns="0" rtlCol="0" anchor="ctr"/>
           <a:lstStyle/>
           <a:p>
-            <a:pPr algn="ctr" indent="0" marL="0">
+            <a:pPr marL="0" indent="0" algn="ctr">
               <a:buNone/>
             </a:pPr>
             <a:r>
@@ -9805,7 +9580,7 @@
           <a:bodyPr wrap="square" lIns="0" tIns="0" rIns="0" bIns="0" rtlCol="0" anchor="ctr"/>
           <a:lstStyle/>
           <a:p>
-            <a:pPr algn="ctr" indent="0" marL="0">
+            <a:pPr marL="0" indent="0" algn="ctr">
               <a:buNone/>
             </a:pPr>
             <a:r>
@@ -9844,7 +9619,7 @@
           <a:bodyPr wrap="square" lIns="0" tIns="0" rIns="0" bIns="0" rtlCol="0" anchor="ctr"/>
           <a:lstStyle/>
           <a:p>
-            <a:pPr algn="ctr" indent="0" marL="0">
+            <a:pPr marL="0" indent="0" algn="ctr">
               <a:buNone/>
             </a:pPr>
             <a:r>
@@ -9908,7 +9683,7 @@
             <a:prstDash val="solid"/>
           </a:ln>
           <a:effectLst>
-            <a:outerShdw sx="100000" sy="100000" kx="0" ky="0" algn="bl" rotWithShape="0" blurRad="88900" dist="25400" dir="8100000">
+            <a:outerShdw blurRad="88900" dist="25400" dir="8100000" algn="bl" rotWithShape="0">
               <a:srgbClr val="1B2A3A">
                 <a:alpha val="13000"/>
               </a:srgbClr>
@@ -9957,7 +9732,7 @@
           <a:bodyPr wrap="square" lIns="0" tIns="0" rIns="0" bIns="0" rtlCol="0" anchor="ctr"/>
           <a:lstStyle/>
           <a:p>
-            <a:pPr algn="ctr" indent="0" marL="0">
+            <a:pPr marL="0" indent="0" algn="ctr">
               <a:buNone/>
             </a:pPr>
             <a:r>
@@ -9996,7 +9771,7 @@
           <a:bodyPr wrap="square" lIns="0" tIns="0" rIns="0" bIns="0" rtlCol="0" anchor="ctr"/>
           <a:lstStyle/>
           <a:p>
-            <a:pPr algn="ctr" indent="0" marL="0">
+            <a:pPr marL="0" indent="0" algn="ctr">
               <a:buNone/>
             </a:pPr>
             <a:r>
@@ -10035,7 +9810,7 @@
           <a:bodyPr wrap="square" lIns="0" tIns="0" rIns="0" bIns="0" rtlCol="0" anchor="ctr"/>
           <a:lstStyle/>
           <a:p>
-            <a:pPr algn="ctr" indent="0" marL="0">
+            <a:pPr marL="0" indent="0" algn="ctr">
               <a:buNone/>
             </a:pPr>
             <a:r>
@@ -10074,7 +9849,7 @@
           <a:bodyPr wrap="square" lIns="0" tIns="0" rIns="0" bIns="0" rtlCol="0" anchor="ctr"/>
           <a:lstStyle/>
           <a:p>
-            <a:pPr algn="ctr" indent="0" marL="0">
+            <a:pPr marL="0" indent="0" algn="ctr">
               <a:buNone/>
             </a:pPr>
             <a:r>
@@ -10113,7 +9888,7 @@
           <a:bodyPr wrap="square" lIns="0" tIns="0" rIns="0" bIns="0" rtlCol="0" anchor="ctr"/>
           <a:lstStyle/>
           <a:p>
-            <a:pPr algn="ctr" indent="0" marL="0">
+            <a:pPr marL="0" indent="0" algn="ctr">
               <a:buNone/>
             </a:pPr>
             <a:r>
@@ -10147,6 +9922,7 @@
         <a:solidFill>
           <a:srgbClr val="FFFFFF"/>
         </a:solidFill>
+        <a:effectLst/>
       </p:bgPr>
     </p:bg>
     <p:spTree>
@@ -10184,11 +9960,11 @@
           <a:bodyPr wrap="square" lIns="0" tIns="0" rIns="0" bIns="0" rtlCol="0" anchor="ctr"/>
           <a:lstStyle/>
           <a:p>
-            <a:pPr indent="0" marL="0">
-              <a:buNone/>
-            </a:pPr>
-            <a:r>
-              <a:rPr lang="en-US" sz="1100" b="1" spc="200" kern="0" dirty="0">
+            <a:pPr marL="0" indent="0">
+              <a:buNone/>
+            </a:pPr>
+            <a:r>
+              <a:rPr lang="en-US" sz="1100" b="1" kern="0" spc="200" dirty="0">
                 <a:solidFill>
                   <a:srgbClr val="2B6CB0"/>
                 </a:solidFill>
@@ -10223,7 +9999,7 @@
           <a:bodyPr wrap="square" lIns="0" tIns="0" rIns="0" bIns="0" rtlCol="0" anchor="ctr"/>
           <a:lstStyle/>
           <a:p>
-            <a:pPr indent="0" marL="0">
+            <a:pPr marL="0" indent="0">
               <a:buNone/>
             </a:pPr>
             <a:r>
@@ -10243,14 +10019,14 @@
       </p:sp>
       <p:pic>
         <p:nvPicPr>
-          <p:cNvPr id="4" name="Image 0" descr="architecture.png">    </p:cNvPr>
+          <p:cNvPr id="4" name="Image 0" descr="architecture.png"/>
           <p:cNvPicPr>
             <a:picLocks noChangeAspect="1"/>
           </p:cNvPicPr>
           <p:nvPr/>
         </p:nvPicPr>
         <p:blipFill>
-          <a:blip r:embed="rId1"/>
+          <a:blip r:embed="rId3"/>
           <a:stretch>
             <a:fillRect/>
           </a:stretch>
@@ -10291,7 +10067,7 @@
             <a:prstDash val="solid"/>
           </a:ln>
           <a:effectLst>
-            <a:outerShdw sx="100000" sy="100000" kx="0" ky="0" algn="bl" rotWithShape="0" blurRad="88900" dist="25400" dir="8100000">
+            <a:outerShdw blurRad="88900" dist="25400" dir="8100000" algn="bl" rotWithShape="0">
               <a:srgbClr val="1B2A3A">
                 <a:alpha val="13000"/>
               </a:srgbClr>
@@ -10320,7 +10096,7 @@
           <a:bodyPr wrap="square" lIns="0" tIns="0" rIns="0" bIns="0" rtlCol="0" anchor="ctr"/>
           <a:lstStyle/>
           <a:p>
-            <a:pPr indent="0" marL="0">
+            <a:pPr marL="0" indent="0">
               <a:buNone/>
             </a:pPr>
             <a:r>
@@ -10359,7 +10135,7 @@
           <a:bodyPr wrap="square" lIns="0" tIns="0" rIns="0" bIns="0" rtlCol="0" anchor="ctr"/>
           <a:lstStyle/>
           <a:p>
-            <a:pPr indent="0" marL="0">
+            <a:pPr marL="0" indent="0">
               <a:lnSpc>
                 <a:spcPct val="102000"/>
               </a:lnSpc>
@@ -10406,7 +10182,7 @@
             <a:prstDash val="solid"/>
           </a:ln>
           <a:effectLst>
-            <a:outerShdw sx="100000" sy="100000" kx="0" ky="0" algn="bl" rotWithShape="0" blurRad="88900" dist="25400" dir="8100000">
+            <a:outerShdw blurRad="88900" dist="25400" dir="8100000" algn="bl" rotWithShape="0">
               <a:srgbClr val="1B2A3A">
                 <a:alpha val="13000"/>
               </a:srgbClr>
@@ -10435,7 +10211,7 @@
           <a:bodyPr wrap="square" lIns="0" tIns="0" rIns="0" bIns="0" rtlCol="0" anchor="ctr"/>
           <a:lstStyle/>
           <a:p>
-            <a:pPr indent="0" marL="0">
+            <a:pPr marL="0" indent="0">
               <a:buNone/>
             </a:pPr>
             <a:r>
@@ -10474,7 +10250,7 @@
           <a:bodyPr wrap="square" lIns="0" tIns="0" rIns="0" bIns="0" rtlCol="0" anchor="ctr"/>
           <a:lstStyle/>
           <a:p>
-            <a:pPr indent="0" marL="0">
+            <a:pPr marL="0" indent="0">
               <a:lnSpc>
                 <a:spcPct val="102000"/>
               </a:lnSpc>
@@ -10521,7 +10297,7 @@
             <a:prstDash val="solid"/>
           </a:ln>
           <a:effectLst>
-            <a:outerShdw sx="100000" sy="100000" kx="0" ky="0" algn="bl" rotWithShape="0" blurRad="88900" dist="25400" dir="8100000">
+            <a:outerShdw blurRad="88900" dist="25400" dir="8100000" algn="bl" rotWithShape="0">
               <a:srgbClr val="1B2A3A">
                 <a:alpha val="13000"/>
               </a:srgbClr>
@@ -10550,7 +10326,7 @@
           <a:bodyPr wrap="square" lIns="0" tIns="0" rIns="0" bIns="0" rtlCol="0" anchor="ctr"/>
           <a:lstStyle/>
           <a:p>
-            <a:pPr indent="0" marL="0">
+            <a:pPr marL="0" indent="0">
               <a:buNone/>
             </a:pPr>
             <a:r>
@@ -10589,7 +10365,7 @@
           <a:bodyPr wrap="square" lIns="0" tIns="0" rIns="0" bIns="0" rtlCol="0" anchor="ctr"/>
           <a:lstStyle/>
           <a:p>
-            <a:pPr indent="0" marL="0">
+            <a:pPr marL="0" indent="0">
               <a:lnSpc>
                 <a:spcPct val="102000"/>
               </a:lnSpc>
@@ -10626,6 +10402,7 @@
         <a:solidFill>
           <a:srgbClr val="FFFFFF"/>
         </a:solidFill>
+        <a:effectLst/>
       </p:bgPr>
     </p:bg>
     <p:spTree>
@@ -10663,11 +10440,11 @@
           <a:bodyPr wrap="square" lIns="0" tIns="0" rIns="0" bIns="0" rtlCol="0" anchor="ctr"/>
           <a:lstStyle/>
           <a:p>
-            <a:pPr indent="0" marL="0">
-              <a:buNone/>
-            </a:pPr>
-            <a:r>
-              <a:rPr lang="en-US" sz="1100" b="1" spc="200" kern="0" dirty="0">
+            <a:pPr marL="0" indent="0">
+              <a:buNone/>
+            </a:pPr>
+            <a:r>
+              <a:rPr lang="en-US" sz="1100" b="1" kern="0" spc="200" dirty="0">
                 <a:solidFill>
                   <a:srgbClr val="2B6CB0"/>
                 </a:solidFill>
@@ -10702,7 +10479,7 @@
           <a:bodyPr wrap="square" lIns="0" tIns="0" rIns="0" bIns="0" rtlCol="0" anchor="ctr"/>
           <a:lstStyle/>
           <a:p>
-            <a:pPr indent="0" marL="0">
+            <a:pPr marL="0" indent="0">
               <a:buNone/>
             </a:pPr>
             <a:r>
@@ -10746,7 +10523,7 @@
             <a:prstDash val="solid"/>
           </a:ln>
           <a:effectLst>
-            <a:outerShdw sx="100000" sy="100000" kx="0" ky="0" algn="bl" rotWithShape="0" blurRad="88900" dist="25400" dir="8100000">
+            <a:outerShdw blurRad="88900" dist="25400" dir="8100000" algn="bl" rotWithShape="0">
               <a:srgbClr val="1B2A3A">
                 <a:alpha val="13000"/>
               </a:srgbClr>
@@ -10775,11 +10552,11 @@
           <a:bodyPr wrap="square" lIns="0" tIns="0" rIns="0" bIns="0" rtlCol="0" anchor="ctr"/>
           <a:lstStyle/>
           <a:p>
-            <a:pPr indent="0" marL="0">
-              <a:buNone/>
-            </a:pPr>
-            <a:r>
-              <a:rPr lang="en-US" sz="1150" b="1" spc="50" kern="0" dirty="0">
+            <a:pPr marL="0" indent="0">
+              <a:buNone/>
+            </a:pPr>
+            <a:r>
+              <a:rPr lang="en-US" sz="1150" b="1" kern="0" spc="50" dirty="0">
                 <a:solidFill>
                   <a:srgbClr val="5B7085"/>
                 </a:solidFill>
@@ -10925,7 +10702,7 @@
             <a:prstDash val="solid"/>
           </a:ln>
           <a:effectLst>
-            <a:outerShdw sx="100000" sy="100000" kx="0" ky="0" algn="bl" rotWithShape="0" blurRad="88900" dist="25400" dir="8100000">
+            <a:outerShdw blurRad="88900" dist="25400" dir="8100000" algn="bl" rotWithShape="0">
               <a:srgbClr val="1B2A3A">
                 <a:alpha val="13000"/>
               </a:srgbClr>
@@ -10954,11 +10731,11 @@
           <a:bodyPr wrap="square" lIns="0" tIns="0" rIns="0" bIns="0" rtlCol="0" anchor="ctr"/>
           <a:lstStyle/>
           <a:p>
-            <a:pPr indent="0" marL="0">
-              <a:buNone/>
-            </a:pPr>
-            <a:r>
-              <a:rPr lang="en-US" sz="1150" b="1" spc="50" kern="0" dirty="0">
+            <a:pPr marL="0" indent="0">
+              <a:buNone/>
+            </a:pPr>
+            <a:r>
+              <a:rPr lang="en-US" sz="1150" b="1" kern="0" spc="50" dirty="0">
                 <a:solidFill>
                   <a:srgbClr val="2B6CB0"/>
                 </a:solidFill>
@@ -11099,7 +10876,7 @@
           <a:bodyPr wrap="square" lIns="0" tIns="0" rIns="0" bIns="0" rtlCol="0" anchor="ctr"/>
           <a:lstStyle/>
           <a:p>
-            <a:pPr algn="ctr" indent="0" marL="0">
+            <a:pPr marL="0" indent="0" algn="ctr">
               <a:buNone/>
             </a:pPr>
             <a:r>
@@ -11133,6 +10910,7 @@
         <a:solidFill>
           <a:srgbClr val="FFFFFF"/>
         </a:solidFill>
+        <a:effectLst/>
       </p:bgPr>
     </p:bg>
     <p:spTree>
@@ -11170,11 +10948,11 @@
           <a:bodyPr wrap="square" lIns="0" tIns="0" rIns="0" bIns="0" rtlCol="0" anchor="ctr"/>
           <a:lstStyle/>
           <a:p>
-            <a:pPr indent="0" marL="0">
-              <a:buNone/>
-            </a:pPr>
-            <a:r>
-              <a:rPr lang="en-US" sz="1100" b="1" spc="200" kern="0" dirty="0">
+            <a:pPr marL="0" indent="0">
+              <a:buNone/>
+            </a:pPr>
+            <a:r>
+              <a:rPr lang="en-US" sz="1100" b="1" kern="0" spc="200" dirty="0">
                 <a:solidFill>
                   <a:srgbClr val="2B6CB0"/>
                 </a:solidFill>
@@ -11209,7 +10987,7 @@
           <a:bodyPr wrap="square" lIns="0" tIns="0" rIns="0" bIns="0" rtlCol="0" anchor="ctr"/>
           <a:lstStyle/>
           <a:p>
-            <a:pPr indent="0" marL="0">
+            <a:pPr marL="0" indent="0">
               <a:buNone/>
             </a:pPr>
             <a:r>
@@ -11253,7 +11031,7 @@
             <a:prstDash val="solid"/>
           </a:ln>
           <a:effectLst>
-            <a:outerShdw sx="100000" sy="100000" kx="0" ky="0" algn="bl" rotWithShape="0" blurRad="88900" dist="25400" dir="8100000">
+            <a:outerShdw blurRad="88900" dist="25400" dir="8100000" algn="bl" rotWithShape="0">
               <a:srgbClr val="1B2A3A">
                 <a:alpha val="13000"/>
               </a:srgbClr>
@@ -11302,7 +11080,7 @@
           <a:bodyPr wrap="square" lIns="0" tIns="0" rIns="0" bIns="0" rtlCol="0" anchor="ctr"/>
           <a:lstStyle/>
           <a:p>
-            <a:pPr algn="ctr" indent="0" marL="0">
+            <a:pPr marL="0" indent="0" algn="ctr">
               <a:buNone/>
             </a:pPr>
             <a:r>
@@ -11341,7 +11119,7 @@
           <a:bodyPr wrap="square" lIns="0" tIns="0" rIns="0" bIns="0" rtlCol="0" anchor="ctr"/>
           <a:lstStyle/>
           <a:p>
-            <a:pPr algn="ctr" indent="0" marL="0">
+            <a:pPr marL="0" indent="0" algn="ctr">
               <a:buNone/>
             </a:pPr>
             <a:r>
@@ -11380,7 +11158,7 @@
           <a:bodyPr wrap="square" lIns="0" tIns="0" rIns="0" bIns="0" rtlCol="0" anchor="ctr"/>
           <a:lstStyle/>
           <a:p>
-            <a:pPr algn="ctr" indent="0" marL="0">
+            <a:pPr marL="0" indent="0" algn="ctr">
               <a:buNone/>
             </a:pPr>
             <a:r>
@@ -11419,7 +11197,7 @@
           <a:bodyPr wrap="square" lIns="0" tIns="0" rIns="0" bIns="0" rtlCol="0" anchor="ctr"/>
           <a:lstStyle/>
           <a:p>
-            <a:pPr algn="ctr" indent="0" marL="0">
+            <a:pPr marL="0" indent="0" algn="ctr">
               <a:buNone/>
             </a:pPr>
             <a:r>
@@ -11463,7 +11241,7 @@
             <a:prstDash val="solid"/>
           </a:ln>
           <a:effectLst>
-            <a:outerShdw sx="100000" sy="100000" kx="0" ky="0" algn="bl" rotWithShape="0" blurRad="88900" dist="25400" dir="8100000">
+            <a:outerShdw blurRad="88900" dist="25400" dir="8100000" algn="bl" rotWithShape="0">
               <a:srgbClr val="1B2A3A">
                 <a:alpha val="13000"/>
               </a:srgbClr>
@@ -11512,7 +11290,7 @@
           <a:bodyPr wrap="square" lIns="0" tIns="0" rIns="0" bIns="0" rtlCol="0" anchor="ctr"/>
           <a:lstStyle/>
           <a:p>
-            <a:pPr algn="ctr" indent="0" marL="0">
+            <a:pPr marL="0" indent="0" algn="ctr">
               <a:buNone/>
             </a:pPr>
             <a:r>
@@ -11551,7 +11329,7 @@
           <a:bodyPr wrap="square" lIns="0" tIns="0" rIns="0" bIns="0" rtlCol="0" anchor="ctr"/>
           <a:lstStyle/>
           <a:p>
-            <a:pPr algn="ctr" indent="0" marL="0">
+            <a:pPr marL="0" indent="0" algn="ctr">
               <a:buNone/>
             </a:pPr>
             <a:r>
@@ -11590,7 +11368,7 @@
           <a:bodyPr wrap="square" lIns="0" tIns="0" rIns="0" bIns="0" rtlCol="0" anchor="ctr"/>
           <a:lstStyle/>
           <a:p>
-            <a:pPr algn="ctr" indent="0" marL="0">
+            <a:pPr marL="0" indent="0" algn="ctr">
               <a:buNone/>
             </a:pPr>
             <a:r>
@@ -11629,7 +11407,7 @@
           <a:bodyPr wrap="square" lIns="0" tIns="0" rIns="0" bIns="0" rtlCol="0" anchor="ctr"/>
           <a:lstStyle/>
           <a:p>
-            <a:pPr algn="ctr" indent="0" marL="0">
+            <a:pPr marL="0" indent="0" algn="ctr">
               <a:buNone/>
             </a:pPr>
             <a:r>
@@ -11673,7 +11451,7 @@
             <a:prstDash val="solid"/>
           </a:ln>
           <a:effectLst>
-            <a:outerShdw sx="100000" sy="100000" kx="0" ky="0" algn="bl" rotWithShape="0" blurRad="88900" dist="25400" dir="8100000">
+            <a:outerShdw blurRad="88900" dist="25400" dir="8100000" algn="bl" rotWithShape="0">
               <a:srgbClr val="1B2A3A">
                 <a:alpha val="13000"/>
               </a:srgbClr>
@@ -11722,7 +11500,7 @@
           <a:bodyPr wrap="square" lIns="0" tIns="0" rIns="0" bIns="0" rtlCol="0" anchor="ctr"/>
           <a:lstStyle/>
           <a:p>
-            <a:pPr algn="ctr" indent="0" marL="0">
+            <a:pPr marL="0" indent="0" algn="ctr">
               <a:buNone/>
             </a:pPr>
             <a:r>
@@ -11761,7 +11539,7 @@
           <a:bodyPr wrap="square" lIns="0" tIns="0" rIns="0" bIns="0" rtlCol="0" anchor="ctr"/>
           <a:lstStyle/>
           <a:p>
-            <a:pPr algn="ctr" indent="0" marL="0">
+            <a:pPr marL="0" indent="0" algn="ctr">
               <a:buNone/>
             </a:pPr>
             <a:r>
@@ -11800,7 +11578,7 @@
           <a:bodyPr wrap="square" lIns="0" tIns="0" rIns="0" bIns="0" rtlCol="0" anchor="ctr"/>
           <a:lstStyle/>
           <a:p>
-            <a:pPr algn="ctr" indent="0" marL="0">
+            <a:pPr marL="0" indent="0" algn="ctr">
               <a:buNone/>
             </a:pPr>
             <a:r>
@@ -11839,7 +11617,7 @@
           <a:bodyPr wrap="square" lIns="0" tIns="0" rIns="0" bIns="0" rtlCol="0" anchor="ctr"/>
           <a:lstStyle/>
           <a:p>
-            <a:pPr algn="ctr" indent="0" marL="0">
+            <a:pPr marL="0" indent="0" algn="ctr">
               <a:buNone/>
             </a:pPr>
             <a:r>
@@ -11883,7 +11661,7 @@
             <a:prstDash val="solid"/>
           </a:ln>
           <a:effectLst>
-            <a:outerShdw sx="100000" sy="100000" kx="0" ky="0" algn="bl" rotWithShape="0" blurRad="88900" dist="25400" dir="8100000">
+            <a:outerShdw blurRad="88900" dist="25400" dir="8100000" algn="bl" rotWithShape="0">
               <a:srgbClr val="1B2A3A">
                 <a:alpha val="13000"/>
               </a:srgbClr>
@@ -11932,7 +11710,7 @@
           <a:bodyPr wrap="square" lIns="0" tIns="0" rIns="0" bIns="0" rtlCol="0" anchor="ctr"/>
           <a:lstStyle/>
           <a:p>
-            <a:pPr algn="ctr" indent="0" marL="0">
+            <a:pPr marL="0" indent="0" algn="ctr">
               <a:buNone/>
             </a:pPr>
             <a:r>
@@ -11971,7 +11749,7 @@
           <a:bodyPr wrap="square" lIns="0" tIns="0" rIns="0" bIns="0" rtlCol="0" anchor="ctr"/>
           <a:lstStyle/>
           <a:p>
-            <a:pPr algn="ctr" indent="0" marL="0">
+            <a:pPr marL="0" indent="0" algn="ctr">
               <a:buNone/>
             </a:pPr>
             <a:r>
@@ -12010,7 +11788,7 @@
           <a:bodyPr wrap="square" lIns="0" tIns="0" rIns="0" bIns="0" rtlCol="0" anchor="ctr"/>
           <a:lstStyle/>
           <a:p>
-            <a:pPr algn="ctr" indent="0" marL="0">
+            <a:pPr marL="0" indent="0" algn="ctr">
               <a:buNone/>
             </a:pPr>
             <a:r>
@@ -12049,7 +11827,7 @@
           <a:bodyPr wrap="square" lIns="0" tIns="0" rIns="0" bIns="0" rtlCol="0" anchor="ctr"/>
           <a:lstStyle/>
           <a:p>
-            <a:pPr algn="ctr" indent="0" marL="0">
+            <a:pPr marL="0" indent="0" algn="ctr">
               <a:buNone/>
             </a:pPr>
             <a:r>
@@ -12093,7 +11871,7 @@
             <a:prstDash val="solid"/>
           </a:ln>
           <a:effectLst>
-            <a:outerShdw sx="100000" sy="100000" kx="0" ky="0" algn="bl" rotWithShape="0" blurRad="88900" dist="25400" dir="8100000">
+            <a:outerShdw blurRad="88900" dist="25400" dir="8100000" algn="bl" rotWithShape="0">
               <a:srgbClr val="1B2A3A">
                 <a:alpha val="13000"/>
               </a:srgbClr>
@@ -12142,7 +11920,7 @@
           <a:bodyPr wrap="square" lIns="0" tIns="0" rIns="0" bIns="0" rtlCol="0" anchor="ctr"/>
           <a:lstStyle/>
           <a:p>
-            <a:pPr algn="ctr" indent="0" marL="0">
+            <a:pPr marL="0" indent="0" algn="ctr">
               <a:buNone/>
             </a:pPr>
             <a:r>
@@ -12181,7 +11959,7 @@
           <a:bodyPr wrap="square" lIns="0" tIns="0" rIns="0" bIns="0" rtlCol="0" anchor="ctr"/>
           <a:lstStyle/>
           <a:p>
-            <a:pPr algn="ctr" indent="0" marL="0">
+            <a:pPr marL="0" indent="0" algn="ctr">
               <a:buNone/>
             </a:pPr>
             <a:r>
@@ -12220,7 +11998,7 @@
           <a:bodyPr wrap="square" lIns="0" tIns="0" rIns="0" bIns="0" rtlCol="0" anchor="ctr"/>
           <a:lstStyle/>
           <a:p>
-            <a:pPr algn="ctr" indent="0" marL="0">
+            <a:pPr marL="0" indent="0" algn="ctr">
               <a:buNone/>
             </a:pPr>
             <a:r>
@@ -12259,7 +12037,7 @@
           <a:bodyPr wrap="square" lIns="0" tIns="0" rIns="0" bIns="0" rtlCol="0" anchor="ctr"/>
           <a:lstStyle/>
           <a:p>
-            <a:pPr algn="ctr" indent="0" marL="0">
+            <a:pPr marL="0" indent="0" algn="ctr">
               <a:buNone/>
             </a:pPr>
             <a:r>
@@ -12303,7 +12081,7 @@
             <a:prstDash val="solid"/>
           </a:ln>
           <a:effectLst>
-            <a:outerShdw sx="100000" sy="100000" kx="0" ky="0" algn="bl" rotWithShape="0" blurRad="88900" dist="25400" dir="8100000">
+            <a:outerShdw blurRad="88900" dist="25400" dir="8100000" algn="bl" rotWithShape="0">
               <a:srgbClr val="1B2A3A">
                 <a:alpha val="13000"/>
               </a:srgbClr>
@@ -12352,7 +12130,7 @@
           <a:bodyPr wrap="square" lIns="0" tIns="0" rIns="0" bIns="0" rtlCol="0" anchor="ctr"/>
           <a:lstStyle/>
           <a:p>
-            <a:pPr algn="ctr" indent="0" marL="0">
+            <a:pPr marL="0" indent="0" algn="ctr">
               <a:buNone/>
             </a:pPr>
             <a:r>
@@ -12391,7 +12169,7 @@
           <a:bodyPr wrap="square" lIns="0" tIns="0" rIns="0" bIns="0" rtlCol="0" anchor="ctr"/>
           <a:lstStyle/>
           <a:p>
-            <a:pPr algn="ctr" indent="0" marL="0">
+            <a:pPr marL="0" indent="0" algn="ctr">
               <a:buNone/>
             </a:pPr>
             <a:r>
@@ -12430,7 +12208,7 @@
           <a:bodyPr wrap="square" lIns="0" tIns="0" rIns="0" bIns="0" rtlCol="0" anchor="ctr"/>
           <a:lstStyle/>
           <a:p>
-            <a:pPr algn="ctr" indent="0" marL="0">
+            <a:pPr marL="0" indent="0" algn="ctr">
               <a:buNone/>
             </a:pPr>
             <a:r>
@@ -12469,7 +12247,7 @@
           <a:bodyPr wrap="square" lIns="0" tIns="0" rIns="0" bIns="0" rtlCol="0" anchor="ctr"/>
           <a:lstStyle/>
           <a:p>
-            <a:pPr algn="ctr" indent="0" marL="0">
+            <a:pPr marL="0" indent="0" algn="ctr">
               <a:buNone/>
             </a:pPr>
             <a:r>
@@ -12513,7 +12291,7 @@
             <a:prstDash val="solid"/>
           </a:ln>
           <a:effectLst>
-            <a:outerShdw sx="100000" sy="100000" kx="0" ky="0" algn="bl" rotWithShape="0" blurRad="88900" dist="25400" dir="8100000">
+            <a:outerShdw blurRad="88900" dist="25400" dir="8100000" algn="bl" rotWithShape="0">
               <a:srgbClr val="1B2A3A">
                 <a:alpha val="13000"/>
               </a:srgbClr>
@@ -12542,7 +12320,7 @@
           <a:bodyPr wrap="square" lIns="0" tIns="0" rIns="0" bIns="0" rtlCol="0" anchor="ctr"/>
           <a:lstStyle/>
           <a:p>
-            <a:pPr indent="0" marL="0">
+            <a:pPr marL="0" indent="0">
               <a:buNone/>
             </a:pPr>
             <a:r>
@@ -12556,9 +12334,6 @@
               </a:rPr>
               <a:t>STEP 4.5 — Plant impact  [ROADMAP — not in the prototype]: </a:t>
             </a:r>
-            <a:pPr indent="0" marL="0">
-              <a:buNone/>
-            </a:pPr>
             <a:r>
               <a:rPr lang="en-US" sz="1200" dirty="0">
                 <a:solidFill>
@@ -12590,6 +12365,7 @@
         <a:solidFill>
           <a:srgbClr val="FFFFFF"/>
         </a:solidFill>
+        <a:effectLst/>
       </p:bgPr>
     </p:bg>
     <p:spTree>
@@ -12627,11 +12403,11 @@
           <a:bodyPr wrap="square" lIns="0" tIns="0" rIns="0" bIns="0" rtlCol="0" anchor="ctr"/>
           <a:lstStyle/>
           <a:p>
-            <a:pPr indent="0" marL="0">
-              <a:buNone/>
-            </a:pPr>
-            <a:r>
-              <a:rPr lang="en-US" sz="1100" b="1" spc="200" kern="0" dirty="0">
+            <a:pPr marL="0" indent="0">
+              <a:buNone/>
+            </a:pPr>
+            <a:r>
+              <a:rPr lang="en-US" sz="1100" b="1" kern="0" spc="200" dirty="0">
                 <a:solidFill>
                   <a:srgbClr val="2B6CB0"/>
                 </a:solidFill>
@@ -12666,7 +12442,7 @@
           <a:bodyPr wrap="square" lIns="0" tIns="0" rIns="0" bIns="0" rtlCol="0" anchor="ctr"/>
           <a:lstStyle/>
           <a:p>
-            <a:pPr indent="0" marL="0">
+            <a:pPr marL="0" indent="0">
               <a:buNone/>
             </a:pPr>
             <a:r>
@@ -12705,7 +12481,7 @@
           <a:bodyPr wrap="square" lIns="0" tIns="0" rIns="0" bIns="0" rtlCol="0" anchor="ctr"/>
           <a:lstStyle/>
           <a:p>
-            <a:pPr indent="0" marL="0">
+            <a:pPr marL="0" indent="0">
               <a:lnSpc>
                 <a:spcPct val="112000"/>
               </a:lnSpc>
@@ -12722,14 +12498,72 @@
               </a:rPr>
               <a:t>Remaining Useful Life</a:t>
             </a:r>
-            <a:pPr indent="0" marL="0">
+            <a:r>
+              <a:rPr lang="en-US" sz="1400" dirty="0">
+                <a:solidFill>
+                  <a:srgbClr val="16202E"/>
+                </a:solidFill>
+                <a:latin typeface="Calibri" pitchFamily="34" charset="0"/>
+                <a:ea typeface="Calibri" pitchFamily="34" charset="-122"/>
+                <a:cs typeface="Calibri" pitchFamily="34" charset="-120"/>
+              </a:rPr>
+              <a:t> + 30-day failure probability, from a Random Forest trained on per-asset-type </a:t>
+            </a:r>
+            <a:r>
+              <a:rPr lang="en-US" sz="1400" b="1" i="1" dirty="0">
+                <a:solidFill>
+                  <a:srgbClr val="2B6CB0"/>
+                </a:solidFill>
+                <a:latin typeface="Calibri" pitchFamily="34" charset="0"/>
+                <a:ea typeface="Calibri" pitchFamily="34" charset="-122"/>
+                <a:cs typeface="Calibri" pitchFamily="34" charset="-120"/>
+              </a:rPr>
+              <a:t>deviations</a:t>
+            </a:r>
+            <a:r>
+              <a:rPr lang="en-US" sz="1400" dirty="0">
+                <a:solidFill>
+                  <a:srgbClr val="16202E"/>
+                </a:solidFill>
+                <a:latin typeface="Calibri" pitchFamily="34" charset="0"/>
+                <a:ea typeface="Calibri" pitchFamily="34" charset="-122"/>
+                <a:cs typeface="Calibri" pitchFamily="34" charset="-120"/>
+              </a:rPr>
+              <a:t> (z-scores vs a healthy baseline). One model serves furnaces, pumps, valves…</a:t>
+            </a:r>
+            <a:endParaRPr lang="en-US" sz="1400" dirty="0"/>
+          </a:p>
+        </p:txBody>
+      </p:sp>
+      <p:sp>
+        <p:nvSpPr>
+          <p:cNvPr id="5" name="Text 3"/>
+          <p:cNvSpPr/>
+          <p:nvPr/>
+        </p:nvSpPr>
+        <p:spPr>
+          <a:xfrm>
+            <a:off x="457200" y="2697480"/>
+            <a:ext cx="3977640" cy="1371600"/>
+          </a:xfrm>
+          <a:prstGeom prst="rect">
+            <a:avLst/>
+          </a:prstGeom>
+          <a:noFill/>
+          <a:ln/>
+        </p:spPr>
+        <p:txBody>
+          <a:bodyPr wrap="square" lIns="0" tIns="0" rIns="0" bIns="0" rtlCol="0" anchor="ctr"/>
+          <a:lstStyle/>
+          <a:p>
+            <a:pPr marL="0" indent="0">
               <a:lnSpc>
                 <a:spcPct val="112000"/>
               </a:lnSpc>
               <a:buNone/>
             </a:pPr>
             <a:r>
-              <a:rPr lang="en-US" sz="1400" dirty="0">
+              <a:rPr lang="en-US" sz="1400" b="1" dirty="0">
                 <a:solidFill>
                   <a:srgbClr val="16202E"/>
                 </a:solidFill>
@@ -12737,138 +12571,56 @@
                 <a:ea typeface="Calibri" pitchFamily="34" charset="-122"/>
                 <a:cs typeface="Calibri" pitchFamily="34" charset="-120"/>
               </a:rPr>
-              <a:t> + 30-day failure probability, from a Random Forest trained on per-asset-type </a:t>
-            </a:r>
-            <a:pPr indent="0" marL="0">
-              <a:lnSpc>
-                <a:spcPct val="112000"/>
-              </a:lnSpc>
-              <a:buNone/>
-            </a:pPr>
-            <a:r>
-              <a:rPr lang="en-US" sz="1400" b="1" i="1" dirty="0">
-                <a:solidFill>
-                  <a:srgbClr val="2B6CB0"/>
+              <a:t>SHAP attribution</a:t>
+            </a:r>
+            <a:r>
+              <a:rPr lang="en-US" sz="1400" dirty="0">
+                <a:solidFill>
+                  <a:srgbClr val="16202E"/>
                 </a:solidFill>
                 <a:latin typeface="Calibri" pitchFamily="34" charset="0"/>
                 <a:ea typeface="Calibri" pitchFamily="34" charset="-122"/>
                 <a:cs typeface="Calibri" pitchFamily="34" charset="-120"/>
               </a:rPr>
-              <a:t>deviations</a:t>
-            </a:r>
-            <a:pPr indent="0" marL="0">
-              <a:lnSpc>
-                <a:spcPct val="112000"/>
-              </a:lnSpc>
-              <a:buNone/>
-            </a:pPr>
-            <a:r>
-              <a:rPr lang="en-US" sz="1400" dirty="0">
-                <a:solidFill>
-                  <a:srgbClr val="16202E"/>
+              <a:t> explains every prediction — negative bars push RUL down (accelerate failure). Falls back to model-agnostic ablation when the SHAP library is absent.</a:t>
+            </a:r>
+            <a:endParaRPr lang="en-US" sz="1400" dirty="0"/>
+          </a:p>
+        </p:txBody>
+      </p:sp>
+      <p:sp>
+        <p:nvSpPr>
+          <p:cNvPr id="6" name="Text 4"/>
+          <p:cNvSpPr/>
+          <p:nvPr/>
+        </p:nvSpPr>
+        <p:spPr>
+          <a:xfrm>
+            <a:off x="4617720" y="1188720"/>
+            <a:ext cx="4069080" cy="274320"/>
+          </a:xfrm>
+          <a:prstGeom prst="rect">
+            <a:avLst/>
+          </a:prstGeom>
+          <a:noFill/>
+          <a:ln/>
+        </p:spPr>
+        <p:txBody>
+          <a:bodyPr wrap="square" lIns="0" tIns="0" rIns="0" bIns="0" rtlCol="0" anchor="ctr"/>
+          <a:lstStyle/>
+          <a:p>
+            <a:pPr marL="0" indent="0" algn="ctr">
+              <a:buNone/>
+            </a:pPr>
+            <a:r>
+              <a:rPr lang="en-US" sz="1200" b="1" dirty="0">
+                <a:solidFill>
+                  <a:srgbClr val="5B7085"/>
                 </a:solidFill>
                 <a:latin typeface="Calibri" pitchFamily="34" charset="0"/>
                 <a:ea typeface="Calibri" pitchFamily="34" charset="-122"/>
                 <a:cs typeface="Calibri" pitchFamily="34" charset="-120"/>
               </a:rPr>
-              <a:t> (z-scores vs a healthy baseline). One model serves furnaces, pumps, valves…</a:t>
-            </a:r>
-            <a:endParaRPr lang="en-US" sz="1400" dirty="0"/>
-          </a:p>
-        </p:txBody>
-      </p:sp>
-      <p:sp>
-        <p:nvSpPr>
-          <p:cNvPr id="5" name="Text 3"/>
-          <p:cNvSpPr/>
-          <p:nvPr/>
-        </p:nvSpPr>
-        <p:spPr>
-          <a:xfrm>
-            <a:off x="457200" y="2697480"/>
-            <a:ext cx="3977640" cy="1371600"/>
-          </a:xfrm>
-          <a:prstGeom prst="rect">
-            <a:avLst/>
-          </a:prstGeom>
-          <a:noFill/>
-          <a:ln/>
-        </p:spPr>
-        <p:txBody>
-          <a:bodyPr wrap="square" lIns="0" tIns="0" rIns="0" bIns="0" rtlCol="0" anchor="ctr"/>
-          <a:lstStyle/>
-          <a:p>
-            <a:pPr indent="0" marL="0">
-              <a:lnSpc>
-                <a:spcPct val="112000"/>
-              </a:lnSpc>
-              <a:buNone/>
-            </a:pPr>
-            <a:r>
-              <a:rPr lang="en-US" sz="1400" b="1" dirty="0">
-                <a:solidFill>
-                  <a:srgbClr val="16202E"/>
-                </a:solidFill>
-                <a:latin typeface="Calibri" pitchFamily="34" charset="0"/>
-                <a:ea typeface="Calibri" pitchFamily="34" charset="-122"/>
-                <a:cs typeface="Calibri" pitchFamily="34" charset="-120"/>
-              </a:rPr>
-              <a:t>SHAP attribution</a:t>
-            </a:r>
-            <a:pPr indent="0" marL="0">
-              <a:lnSpc>
-                <a:spcPct val="112000"/>
-              </a:lnSpc>
-              <a:buNone/>
-            </a:pPr>
-            <a:r>
-              <a:rPr lang="en-US" sz="1400" dirty="0">
-                <a:solidFill>
-                  <a:srgbClr val="16202E"/>
-                </a:solidFill>
-                <a:latin typeface="Calibri" pitchFamily="34" charset="0"/>
-                <a:ea typeface="Calibri" pitchFamily="34" charset="-122"/>
-                <a:cs typeface="Calibri" pitchFamily="34" charset="-120"/>
-              </a:rPr>
-              <a:t> explains every prediction — negative bars push RUL down (accelerate failure). Falls back to model-agnostic ablation when the SHAP library is absent.</a:t>
-            </a:r>
-            <a:endParaRPr lang="en-US" sz="1400" dirty="0"/>
-          </a:p>
-        </p:txBody>
-      </p:sp>
-      <p:sp>
-        <p:nvSpPr>
-          <p:cNvPr id="6" name="Text 4"/>
-          <p:cNvSpPr/>
-          <p:nvPr/>
-        </p:nvSpPr>
-        <p:spPr>
-          <a:xfrm>
-            <a:off x="4617720" y="1188720"/>
-            <a:ext cx="4069080" cy="274320"/>
-          </a:xfrm>
-          <a:prstGeom prst="rect">
-            <a:avLst/>
-          </a:prstGeom>
-          <a:noFill/>
-          <a:ln/>
-        </p:spPr>
-        <p:txBody>
-          <a:bodyPr wrap="square" lIns="0" tIns="0" rIns="0" bIns="0" rtlCol="0" anchor="ctr"/>
-          <a:lstStyle/>
-          <a:p>
-            <a:pPr algn="ctr" indent="0" marL="0">
-              <a:buNone/>
-            </a:pPr>
-            <a:r>
-              <a:rPr lang="en-US" sz="1200" b="1" dirty="0">
-                <a:solidFill>
-                  <a:srgbClr val="5B7085"/>
-                </a:solidFill>
-                <a:latin typeface="Calibri" pitchFamily="34" charset="0"/>
-                <a:ea typeface="Calibri" pitchFamily="34" charset="-122"/>
-                <a:cs typeface="Calibri" pitchFamily="34" charset="-120"/>
-              </a:rPr>
               <a:t>SHAP drivers — Mill Drive Gearbox 5 (example)</a:t>
             </a:r>
             <a:endParaRPr lang="en-US" sz="1200" dirty="0"/>
@@ -12877,7 +12629,7 @@
       </p:sp>
       <p:graphicFrame>
         <p:nvGraphicFramePr>
-          <p:cNvPr id="7" name="Chart 0" descr=""/>
+          <p:cNvPr id="7" name="Chart 0"/>
           <p:cNvGraphicFramePr/>
           <p:nvPr/>
         </p:nvGraphicFramePr>
@@ -12885,9 +12637,9 @@
           <a:off x="4526280" y="1463040"/>
           <a:ext cx="4206240" cy="3200400"/>
         </p:xfrm>
-        <a:graphic xmlns:a="http://schemas.openxmlformats.org/drawingml/2006/main">
+        <a:graphic>
           <a:graphicData uri="http://schemas.openxmlformats.org/drawingml/2006/chart">
-            <c:chart xmlns:c="http://schemas.openxmlformats.org/drawingml/2006/chart" r:id="rId1"/>
+            <c:chart xmlns:c="http://schemas.openxmlformats.org/drawingml/2006/chart" xmlns:r="http://schemas.openxmlformats.org/officeDocument/2006/relationships" r:id="rId3"/>
           </a:graphicData>
         </a:graphic>
       </p:graphicFrame>
@@ -12907,6 +12659,7 @@
         <a:solidFill>
           <a:srgbClr val="FFFFFF"/>
         </a:solidFill>
+        <a:effectLst/>
       </p:bgPr>
     </p:bg>
     <p:spTree>
@@ -12944,11 +12697,11 @@
           <a:bodyPr wrap="square" lIns="0" tIns="0" rIns="0" bIns="0" rtlCol="0" anchor="ctr"/>
           <a:lstStyle/>
           <a:p>
-            <a:pPr indent="0" marL="0">
-              <a:buNone/>
-            </a:pPr>
-            <a:r>
-              <a:rPr lang="en-US" sz="1100" b="1" spc="200" kern="0" dirty="0">
+            <a:pPr marL="0" indent="0">
+              <a:buNone/>
+            </a:pPr>
+            <a:r>
+              <a:rPr lang="en-US" sz="1100" b="1" kern="0" spc="200" dirty="0">
                 <a:solidFill>
                   <a:srgbClr val="2B6CB0"/>
                 </a:solidFill>
@@ -12983,7 +12736,7 @@
           <a:bodyPr wrap="square" lIns="0" tIns="0" rIns="0" bIns="0" rtlCol="0" anchor="ctr"/>
           <a:lstStyle/>
           <a:p>
-            <a:pPr indent="0" marL="0">
+            <a:pPr marL="0" indent="0">
               <a:buNone/>
             </a:pPr>
             <a:r>
@@ -13027,7 +12780,7 @@
             <a:prstDash val="solid"/>
           </a:ln>
           <a:effectLst>
-            <a:outerShdw sx="100000" sy="100000" kx="0" ky="0" algn="bl" rotWithShape="0" blurRad="88900" dist="25400" dir="8100000">
+            <a:outerShdw blurRad="88900" dist="25400" dir="8100000" algn="bl" rotWithShape="0">
               <a:srgbClr val="1B2A3A">
                 <a:alpha val="13000"/>
               </a:srgbClr>
@@ -13056,7 +12809,7 @@
           <a:bodyPr wrap="square" lIns="0" tIns="0" rIns="0" bIns="0" rtlCol="0" anchor="ctr"/>
           <a:lstStyle/>
           <a:p>
-            <a:pPr algn="ctr" indent="0" marL="0">
+            <a:pPr marL="0" indent="0" algn="ctr">
               <a:buNone/>
             </a:pPr>
             <a:r>
@@ -13095,7 +12848,7 @@
           <a:bodyPr wrap="square" lIns="0" tIns="0" rIns="0" bIns="0" rtlCol="0" anchor="ctr"/>
           <a:lstStyle/>
           <a:p>
-            <a:pPr algn="ctr" indent="0" marL="0">
+            <a:pPr marL="0" indent="0" algn="ctr">
               <a:buNone/>
             </a:pPr>
             <a:r>
@@ -13139,7 +12892,7 @@
             <a:prstDash val="solid"/>
           </a:ln>
           <a:effectLst>
-            <a:outerShdw sx="100000" sy="100000" kx="0" ky="0" algn="bl" rotWithShape="0" blurRad="88900" dist="25400" dir="8100000">
+            <a:outerShdw blurRad="88900" dist="25400" dir="8100000" algn="bl" rotWithShape="0">
               <a:srgbClr val="1B2A3A">
                 <a:alpha val="13000"/>
               </a:srgbClr>
@@ -13168,7 +12921,7 @@
           <a:bodyPr wrap="square" lIns="0" tIns="0" rIns="0" bIns="0" rtlCol="0" anchor="ctr"/>
           <a:lstStyle/>
           <a:p>
-            <a:pPr indent="0" marL="0">
+            <a:pPr marL="0" indent="0">
               <a:buNone/>
             </a:pPr>
             <a:r>
@@ -13207,7 +12960,7 @@
           <a:bodyPr wrap="square" lIns="0" tIns="0" rIns="0" bIns="0" rtlCol="0" anchor="ctr"/>
           <a:lstStyle/>
           <a:p>
-            <a:pPr indent="0" marL="0">
+            <a:pPr marL="0" indent="0">
               <a:lnSpc>
                 <a:spcPct val="112000"/>
               </a:lnSpc>
@@ -13254,7 +13007,7 @@
             <a:prstDash val="solid"/>
           </a:ln>
           <a:effectLst>
-            <a:outerShdw sx="100000" sy="100000" kx="0" ky="0" algn="bl" rotWithShape="0" blurRad="88900" dist="25400" dir="8100000">
+            <a:outerShdw blurRad="88900" dist="25400" dir="8100000" algn="bl" rotWithShape="0">
               <a:srgbClr val="1B2A3A">
                 <a:alpha val="13000"/>
               </a:srgbClr>
@@ -13283,7 +13036,7 @@
           <a:bodyPr wrap="square" lIns="0" tIns="0" rIns="0" bIns="0" rtlCol="0" anchor="ctr"/>
           <a:lstStyle/>
           <a:p>
-            <a:pPr indent="0" marL="0">
+            <a:pPr marL="0" indent="0">
               <a:buNone/>
             </a:pPr>
             <a:r>
@@ -13322,7 +13075,7 @@
           <a:bodyPr wrap="square" lIns="0" tIns="0" rIns="0" bIns="0" rtlCol="0" anchor="ctr"/>
           <a:lstStyle/>
           <a:p>
-            <a:pPr indent="0" marL="0">
+            <a:pPr marL="0" indent="0">
               <a:buNone/>
             </a:pPr>
             <a:r>
@@ -13340,7 +13093,7 @@
             <a:endParaRPr lang="en-US" sz="1250" dirty="0"/>
           </a:p>
           <a:p>
-            <a:pPr indent="0" marL="0">
+            <a:pPr marL="0" indent="0">
               <a:buNone/>
             </a:pPr>
             <a:r>
@@ -13358,7 +13111,7 @@
             <a:endParaRPr lang="en-US" sz="1250" dirty="0"/>
           </a:p>
           <a:p>
-            <a:pPr indent="0" marL="0">
+            <a:pPr marL="0" indent="0">
               <a:buNone/>
             </a:pPr>
             <a:r>
@@ -13376,7 +13129,7 @@
             <a:endParaRPr lang="en-US" sz="1250" dirty="0"/>
           </a:p>
           <a:p>
-            <a:pPr indent="0" marL="0">
+            <a:pPr marL="0" indent="0">
               <a:buNone/>
             </a:pPr>
             <a:r>
@@ -13390,9 +13143,6 @@
               </a:rPr>
               <a:t>Recommendation flips:  </a:t>
             </a:r>
-            <a:pPr indent="0" marL="0">
-              <a:buNone/>
-            </a:pPr>
             <a:r>
               <a:rPr lang="en-US" sz="1250" b="1" dirty="0">
                 <a:solidFill>
@@ -13709,4 +13459,299 @@
     </a:ext>
   </a:extLst>
 </a:theme>
+</file>
+
+<file path=ppt/theme/theme2.xml><?xml version="1.0" encoding="utf-8"?>
+<a:theme xmlns:a="http://schemas.openxmlformats.org/drawingml/2006/main" name="Office Theme">
+  <a:themeElements>
+    <a:clrScheme name="Office">
+      <a:dk1>
+        <a:sysClr val="windowText" lastClr="000000"/>
+      </a:dk1>
+      <a:lt1>
+        <a:sysClr val="window" lastClr="FFFFFF"/>
+      </a:lt1>
+      <a:dk2>
+        <a:srgbClr val="44546A"/>
+      </a:dk2>
+      <a:lt2>
+        <a:srgbClr val="E7E6E6"/>
+      </a:lt2>
+      <a:accent1>
+        <a:srgbClr val="4472C4"/>
+      </a:accent1>
+      <a:accent2>
+        <a:srgbClr val="ED7D31"/>
+      </a:accent2>
+      <a:accent3>
+        <a:srgbClr val="A5A5A5"/>
+      </a:accent3>
+      <a:accent4>
+        <a:srgbClr val="FFC000"/>
+      </a:accent4>
+      <a:accent5>
+        <a:srgbClr val="5B9BD5"/>
+      </a:accent5>
+      <a:accent6>
+        <a:srgbClr val="70AD47"/>
+      </a:accent6>
+      <a:hlink>
+        <a:srgbClr val="0563C1"/>
+      </a:hlink>
+      <a:folHlink>
+        <a:srgbClr val="954F72"/>
+      </a:folHlink>
+    </a:clrScheme>
+    <a:fontScheme name="Office">
+      <a:majorFont>
+        <a:latin typeface="Calibri Light" panose="020F0302020204030204"/>
+        <a:ea typeface=""/>
+        <a:cs typeface=""/>
+        <a:font script="Jpan" typeface="游ゴシック Light"/>
+        <a:font script="Hang" typeface="맑은 고딕"/>
+        <a:font script="Hans" typeface="等线 Light"/>
+        <a:font script="Hant" typeface="新細明體"/>
+        <a:font script="Arab" typeface="Times New Roman"/>
+        <a:font script="Hebr" typeface="Times New Roman"/>
+        <a:font script="Thai" typeface="Angsana New"/>
+        <a:font script="Ethi" typeface="Nyala"/>
+        <a:font script="Beng" typeface="Vrinda"/>
+        <a:font script="Gujr" typeface="Shruti"/>
+        <a:font script="Khmr" typeface="MoolBoran"/>
+        <a:font script="Knda" typeface="Tunga"/>
+        <a:font script="Guru" typeface="Raavi"/>
+        <a:font script="Cans" typeface="Euphemia"/>
+        <a:font script="Cher" typeface="Plantagenet Cherokee"/>
+        <a:font script="Yiii" typeface="Microsoft Yi Baiti"/>
+        <a:font script="Tibt" typeface="Microsoft Himalaya"/>
+        <a:font script="Thaa" typeface="MV Boli"/>
+        <a:font script="Deva" typeface="Mangal"/>
+        <a:font script="Telu" typeface="Gautami"/>
+        <a:font script="Taml" typeface="Latha"/>
+        <a:font script="Syrc" typeface="Estrangelo Edessa"/>
+        <a:font script="Orya" typeface="Kalinga"/>
+        <a:font script="Mlym" typeface="Kartika"/>
+        <a:font script="Laoo" typeface="DokChampa"/>
+        <a:font script="Sinh" typeface="Iskoola Pota"/>
+        <a:font script="Mong" typeface="Mongolian Baiti"/>
+        <a:font script="Viet" typeface="Times New Roman"/>
+        <a:font script="Uigh" typeface="Microsoft Uighur"/>
+        <a:font script="Geor" typeface="Sylfaen"/>
+        <a:font script="Armn" typeface="Arial"/>
+        <a:font script="Bugi" typeface="Leelawadee UI"/>
+        <a:font script="Bopo" typeface="Microsoft JhengHei"/>
+        <a:font script="Java" typeface="Javanese Text"/>
+        <a:font script="Lisu" typeface="Segoe UI"/>
+        <a:font script="Mymr" typeface="Myanmar Text"/>
+        <a:font script="Nkoo" typeface="Ebrima"/>
+        <a:font script="Olck" typeface="Nirmala UI"/>
+        <a:font script="Osma" typeface="Ebrima"/>
+        <a:font script="Phag" typeface="Phagspa"/>
+        <a:font script="Syrn" typeface="Estrangelo Edessa"/>
+        <a:font script="Syrj" typeface="Estrangelo Edessa"/>
+        <a:font script="Syre" typeface="Estrangelo Edessa"/>
+        <a:font script="Sora" typeface="Nirmala UI"/>
+        <a:font script="Tale" typeface="Microsoft Tai Le"/>
+        <a:font script="Talu" typeface="Microsoft New Tai Lue"/>
+        <a:font script="Tfng" typeface="Ebrima"/>
+      </a:majorFont>
+      <a:minorFont>
+        <a:latin typeface="Calibri" panose="020F0502020204030204"/>
+        <a:ea typeface=""/>
+        <a:cs typeface=""/>
+        <a:font script="Jpan" typeface="游ゴシック"/>
+        <a:font script="Hang" typeface="맑은 고딕"/>
+        <a:font script="Hans" typeface="等线"/>
+        <a:font script="Hant" typeface="新細明體"/>
+        <a:font script="Arab" typeface="Arial"/>
+        <a:font script="Hebr" typeface="Arial"/>
+        <a:font script="Thai" typeface="Cordia New"/>
+        <a:font script="Ethi" typeface="Nyala"/>
+        <a:font script="Beng" typeface="Vrinda"/>
+        <a:font script="Gujr" typeface="Shruti"/>
+        <a:font script="Khmr" typeface="DaunPenh"/>
+        <a:font script="Knda" typeface="Tunga"/>
+        <a:font script="Guru" typeface="Raavi"/>
+        <a:font script="Cans" typeface="Euphemia"/>
+        <a:font script="Cher" typeface="Plantagenet Cherokee"/>
+        <a:font script="Yiii" typeface="Microsoft Yi Baiti"/>
+        <a:font script="Tibt" typeface="Microsoft Himalaya"/>
+        <a:font script="Thaa" typeface="MV Boli"/>
+        <a:font script="Deva" typeface="Mangal"/>
+        <a:font script="Telu" typeface="Gautami"/>
+        <a:font script="Taml" typeface="Latha"/>
+        <a:font script="Syrc" typeface="Estrangelo Edessa"/>
+        <a:font script="Orya" typeface="Kalinga"/>
+        <a:font script="Mlym" typeface="Kartika"/>
+        <a:font script="Laoo" typeface="DokChampa"/>
+        <a:font script="Sinh" typeface="Iskoola Pota"/>
+        <a:font script="Mong" typeface="Mongolian Baiti"/>
+        <a:font script="Viet" typeface="Arial"/>
+        <a:font script="Uigh" typeface="Microsoft Uighur"/>
+        <a:font script="Geor" typeface="Sylfaen"/>
+        <a:font script="Armn" typeface="Arial"/>
+        <a:font script="Bugi" typeface="Leelawadee UI"/>
+        <a:font script="Bopo" typeface="Microsoft JhengHei"/>
+        <a:font script="Java" typeface="Javanese Text"/>
+        <a:font script="Lisu" typeface="Segoe UI"/>
+        <a:font script="Mymr" typeface="Myanmar Text"/>
+        <a:font script="Nkoo" typeface="Ebrima"/>
+        <a:font script="Olck" typeface="Nirmala UI"/>
+        <a:font script="Osma" typeface="Ebrima"/>
+        <a:font script="Phag" typeface="Phagspa"/>
+        <a:font script="Syrn" typeface="Estrangelo Edessa"/>
+        <a:font script="Syrj" typeface="Estrangelo Edessa"/>
+        <a:font script="Syre" typeface="Estrangelo Edessa"/>
+        <a:font script="Sora" typeface="Nirmala UI"/>
+        <a:font script="Tale" typeface="Microsoft Tai Le"/>
+        <a:font script="Talu" typeface="Microsoft New Tai Lue"/>
+        <a:font script="Tfng" typeface="Ebrima"/>
+      </a:minorFont>
+    </a:fontScheme>
+    <a:fmtScheme name="Office">
+      <a:fillStyleLst>
+        <a:solidFill>
+          <a:schemeClr val="phClr"/>
+        </a:solidFill>
+        <a:gradFill rotWithShape="1">
+          <a:gsLst>
+            <a:gs pos="0">
+              <a:schemeClr val="phClr">
+                <a:lumMod val="110000"/>
+                <a:satMod val="105000"/>
+                <a:tint val="67000"/>
+              </a:schemeClr>
+            </a:gs>
+            <a:gs pos="50000">
+              <a:schemeClr val="phClr">
+                <a:lumMod val="105000"/>
+                <a:satMod val="103000"/>
+                <a:tint val="73000"/>
+              </a:schemeClr>
+            </a:gs>
+            <a:gs pos="100000">
+              <a:schemeClr val="phClr">
+                <a:lumMod val="105000"/>
+                <a:satMod val="109000"/>
+                <a:tint val="81000"/>
+              </a:schemeClr>
+            </a:gs>
+          </a:gsLst>
+          <a:lin ang="5400000" scaled="0"/>
+        </a:gradFill>
+        <a:gradFill rotWithShape="1">
+          <a:gsLst>
+            <a:gs pos="0">
+              <a:schemeClr val="phClr">
+                <a:satMod val="103000"/>
+                <a:lumMod val="102000"/>
+                <a:tint val="94000"/>
+              </a:schemeClr>
+            </a:gs>
+            <a:gs pos="50000">
+              <a:schemeClr val="phClr">
+                <a:satMod val="110000"/>
+                <a:lumMod val="100000"/>
+                <a:shade val="100000"/>
+              </a:schemeClr>
+            </a:gs>
+            <a:gs pos="100000">
+              <a:schemeClr val="phClr">
+                <a:lumMod val="99000"/>
+                <a:satMod val="120000"/>
+                <a:shade val="78000"/>
+              </a:schemeClr>
+            </a:gs>
+          </a:gsLst>
+          <a:lin ang="5400000" scaled="0"/>
+        </a:gradFill>
+      </a:fillStyleLst>
+      <a:lnStyleLst>
+        <a:ln w="6350" cap="flat" cmpd="sng" algn="ctr">
+          <a:solidFill>
+            <a:schemeClr val="phClr"/>
+          </a:solidFill>
+          <a:prstDash val="solid"/>
+          <a:miter lim="800000"/>
+        </a:ln>
+        <a:ln w="12700" cap="flat" cmpd="sng" algn="ctr">
+          <a:solidFill>
+            <a:schemeClr val="phClr"/>
+          </a:solidFill>
+          <a:prstDash val="solid"/>
+          <a:miter lim="800000"/>
+        </a:ln>
+        <a:ln w="19050" cap="flat" cmpd="sng" algn="ctr">
+          <a:solidFill>
+            <a:schemeClr val="phClr"/>
+          </a:solidFill>
+          <a:prstDash val="solid"/>
+          <a:miter lim="800000"/>
+        </a:ln>
+      </a:lnStyleLst>
+      <a:effectStyleLst>
+        <a:effectStyle>
+          <a:effectLst/>
+        </a:effectStyle>
+        <a:effectStyle>
+          <a:effectLst/>
+        </a:effectStyle>
+        <a:effectStyle>
+          <a:effectLst>
+            <a:outerShdw blurRad="57150" dist="19050" dir="5400000" algn="ctr" rotWithShape="0">
+              <a:srgbClr val="000000">
+                <a:alpha val="63000"/>
+              </a:srgbClr>
+            </a:outerShdw>
+          </a:effectLst>
+        </a:effectStyle>
+      </a:effectStyleLst>
+      <a:bgFillStyleLst>
+        <a:solidFill>
+          <a:schemeClr val="phClr"/>
+        </a:solidFill>
+        <a:solidFill>
+          <a:schemeClr val="phClr">
+            <a:tint val="95000"/>
+            <a:satMod val="170000"/>
+          </a:schemeClr>
+        </a:solidFill>
+        <a:gradFill rotWithShape="1">
+          <a:gsLst>
+            <a:gs pos="0">
+              <a:schemeClr val="phClr">
+                <a:tint val="93000"/>
+                <a:satMod val="150000"/>
+                <a:shade val="98000"/>
+                <a:lumMod val="102000"/>
+              </a:schemeClr>
+            </a:gs>
+            <a:gs pos="50000">
+              <a:schemeClr val="phClr">
+                <a:tint val="98000"/>
+                <a:satMod val="130000"/>
+                <a:shade val="90000"/>
+                <a:lumMod val="103000"/>
+              </a:schemeClr>
+            </a:gs>
+            <a:gs pos="100000">
+              <a:schemeClr val="phClr">
+                <a:shade val="63000"/>
+                <a:satMod val="120000"/>
+              </a:schemeClr>
+            </a:gs>
+          </a:gsLst>
+          <a:lin ang="5400000" scaled="0"/>
+        </a:gradFill>
+      </a:bgFillStyleLst>
+    </a:fmtScheme>
+  </a:themeElements>
+  <a:objectDefaults/>
+  <a:extraClrSchemeLst/>
+  <a:extLst>
+    <a:ext uri="{05A4C25C-085E-4340-85A3-A5531E510DB2}">
+      <thm15:themeFamily xmlns:thm15="http://schemas.microsoft.com/office/thememl/2012/main" name="Office Theme" id="{62F939B6-93AF-4DB8-9C6B-D6C7DFDC589F}" vid="{4A3C46E8-61CC-4603-A589-7422A47A8E4A}"/>
+    </a:ext>
+  </a:extLst>
+</a:theme>
 </file>
</xml_diff>